<commit_message>
Adiciona a foto da palestrante nos slides 1, 2 e 41 (PDF, PowerPoint e apresentação online)
Co-Authored-By: Claude Opus 5.5 <noreply@anthropic.com>
Claude-Session: https://claude.ai/code/session_013ZYQJsTZixhcpCnj3mHGtq
</commit_message>
<xml_diff>
--- a/workshop-aba-tea-lacc/apresentacao/Apresentacao_Workshop_ABA_TEA.pptx
+++ b/workshop-aba-tea-lacc/apresentacao/Apresentacao_Workshop_ABA_TEA.pptx
@@ -7904,16 +7904,40 @@
           </a:p>
         </p:txBody>
       </p:sp>
-      <p:sp>
-        <p:nvSpPr>
-          <p:cNvPr id="3" name="TextBox 2"/>
+      <p:pic>
+        <p:nvPicPr>
+          <p:cNvPr id="3" name="Picture 2" descr="foto_circulo_pptx.png"/>
+          <p:cNvPicPr>
+            <a:picLocks noChangeAspect="1"/>
+          </p:cNvPicPr>
+          <p:nvPr/>
+        </p:nvPicPr>
+        <p:blipFill>
+          <a:blip r:embed="rId2"/>
+          <a:stretch>
+            <a:fillRect/>
+          </a:stretch>
+        </p:blipFill>
+        <p:spPr>
+          <a:xfrm>
+            <a:off x="8445500" y="1905000"/>
+            <a:ext cx="2794000" cy="2794000"/>
+          </a:xfrm>
+          <a:prstGeom prst="rect">
+            <a:avLst/>
+          </a:prstGeom>
+        </p:spPr>
+      </p:pic>
+      <p:sp>
+        <p:nvSpPr>
+          <p:cNvPr id="4" name="TextBox 3"/>
           <p:cNvSpPr txBox="1"/>
           <p:nvPr/>
         </p:nvSpPr>
         <p:spPr>
           <a:xfrm>
             <a:off x="1016000" y="1723430"/>
-            <a:ext cx="10464800" cy="247650"/>
+            <a:ext cx="7456170" cy="247650"/>
           </a:xfrm>
           <a:prstGeom prst="rect">
             <a:avLst/>
@@ -7945,14 +7969,14 @@
       </p:sp>
       <p:sp>
         <p:nvSpPr>
-          <p:cNvPr id="4" name="TextBox 3"/>
+          <p:cNvPr id="5" name="TextBox 4"/>
           <p:cNvSpPr txBox="1"/>
           <p:nvPr/>
         </p:nvSpPr>
         <p:spPr>
           <a:xfrm>
             <a:off x="1016000" y="2148880"/>
-            <a:ext cx="10464800" cy="889000"/>
+            <a:ext cx="7456170" cy="889000"/>
           </a:xfrm>
           <a:prstGeom prst="rect">
             <a:avLst/>
@@ -7984,14 +8008,14 @@
       </p:sp>
       <p:sp>
         <p:nvSpPr>
-          <p:cNvPr id="5" name="TextBox 4"/>
+          <p:cNvPr id="6" name="TextBox 5"/>
           <p:cNvSpPr txBox="1"/>
           <p:nvPr/>
         </p:nvSpPr>
         <p:spPr>
           <a:xfrm>
             <a:off x="1016000" y="3215680"/>
-            <a:ext cx="10464800" cy="426641"/>
+            <a:ext cx="7456170" cy="426641"/>
           </a:xfrm>
           <a:prstGeom prst="rect">
             <a:avLst/>
@@ -8023,14 +8047,14 @@
       </p:sp>
       <p:sp>
         <p:nvSpPr>
-          <p:cNvPr id="6" name="TextBox 5"/>
+          <p:cNvPr id="7" name="TextBox 6"/>
           <p:cNvSpPr txBox="1"/>
           <p:nvPr/>
         </p:nvSpPr>
         <p:spPr>
           <a:xfrm>
             <a:off x="1016000" y="4378920"/>
-            <a:ext cx="10464800" cy="330200"/>
+            <a:ext cx="7456170" cy="330200"/>
           </a:xfrm>
           <a:prstGeom prst="rect">
             <a:avLst/>
@@ -8062,14 +8086,14 @@
       </p:sp>
       <p:sp>
         <p:nvSpPr>
-          <p:cNvPr id="7" name="TextBox 6"/>
+          <p:cNvPr id="8" name="TextBox 7"/>
           <p:cNvSpPr txBox="1"/>
           <p:nvPr/>
         </p:nvSpPr>
         <p:spPr>
           <a:xfrm>
             <a:off x="1016000" y="4886920"/>
-            <a:ext cx="10464800" cy="247650"/>
+            <a:ext cx="7456170" cy="247650"/>
           </a:xfrm>
           <a:prstGeom prst="rect">
             <a:avLst/>
@@ -11904,8 +11928,8 @@
         </p:nvSpPr>
         <p:spPr>
           <a:xfrm>
-            <a:off x="1168400" y="1702792"/>
-            <a:ext cx="10307828" cy="481905"/>
+            <a:off x="1168400" y="1159867"/>
+            <a:ext cx="6592824" cy="481905"/>
           </a:xfrm>
           <a:prstGeom prst="rect">
             <a:avLst/>
@@ -11943,8 +11967,8 @@
         </p:nvSpPr>
         <p:spPr>
           <a:xfrm>
-            <a:off x="1168400" y="2438698"/>
-            <a:ext cx="10307828" cy="462260"/>
+            <a:off x="1168400" y="1895773"/>
+            <a:ext cx="6592824" cy="462260"/>
           </a:xfrm>
           <a:prstGeom prst="rect">
             <a:avLst/>
@@ -11982,8 +12006,8 @@
         </p:nvSpPr>
         <p:spPr>
           <a:xfrm>
-            <a:off x="1168400" y="3154958"/>
-            <a:ext cx="10307828" cy="1809750"/>
+            <a:off x="1168400" y="2612033"/>
+            <a:ext cx="6592824" cy="2895600"/>
           </a:xfrm>
           <a:prstGeom prst="rect">
             <a:avLst/>
@@ -12082,9 +12106,33 @@
           </a:p>
         </p:txBody>
       </p:sp>
-      <p:sp>
-        <p:nvSpPr>
-          <p:cNvPr id="6" name="TextBox 5"/>
+      <p:pic>
+        <p:nvPicPr>
+          <p:cNvPr id="6" name="Picture 5" descr="foto_retrato.jpg"/>
+          <p:cNvPicPr>
+            <a:picLocks noChangeAspect="1"/>
+          </p:cNvPicPr>
+          <p:nvPr/>
+        </p:nvPicPr>
+        <p:blipFill>
+          <a:blip r:embed="rId2"/>
+          <a:stretch>
+            <a:fillRect/>
+          </a:stretch>
+        </p:blipFill>
+        <p:spPr>
+          <a:xfrm>
+            <a:off x="8128000" y="1428750"/>
+            <a:ext cx="3048000" cy="3810000"/>
+          </a:xfrm>
+          <a:prstGeom prst="rect">
+            <a:avLst/>
+          </a:prstGeom>
+        </p:spPr>
+      </p:pic>
+      <p:sp>
+        <p:nvSpPr>
+          <p:cNvPr id="7" name="TextBox 6"/>
           <p:cNvSpPr txBox="1"/>
           <p:nvPr/>
         </p:nvSpPr>
@@ -18796,7 +18844,7 @@
         </p:nvSpPr>
         <p:spPr>
           <a:xfrm>
-            <a:off x="1168400" y="1105892"/>
+            <a:off x="1168400" y="1093192"/>
             <a:ext cx="10569448" cy="452735"/>
           </a:xfrm>
           <a:prstGeom prst="rect">
@@ -18965,7 +19013,7 @@
         </p:blipFill>
         <p:spPr>
           <a:xfrm>
-            <a:off x="5537200" y="1787227"/>
+            <a:off x="5537200" y="1774527"/>
             <a:ext cx="5892800" cy="3314700"/>
           </a:xfrm>
           <a:prstGeom prst="rect">
@@ -18981,7 +19029,7 @@
         </p:nvSpPr>
         <p:spPr>
           <a:xfrm>
-            <a:off x="1168400" y="5330527"/>
+            <a:off x="1168400" y="5343227"/>
             <a:ext cx="10569448" cy="231080"/>
           </a:xfrm>
           <a:prstGeom prst="rect">
@@ -24470,15 +24518,39 @@
         <p:nvPr/>
       </p:nvGrpSpPr>
       <p:grpSpPr/>
-      <p:sp>
-        <p:nvSpPr>
-          <p:cNvPr id="2" name="TextBox 1"/>
-          <p:cNvSpPr txBox="1"/>
-          <p:nvPr/>
-        </p:nvSpPr>
-        <p:spPr>
-          <a:xfrm>
-            <a:off x="5217517" y="2290762"/>
+      <p:pic>
+        <p:nvPicPr>
+          <p:cNvPr id="2" name="Picture 1" descr="foto_circulo_pptx.png"/>
+          <p:cNvPicPr>
+            <a:picLocks noChangeAspect="1"/>
+          </p:cNvPicPr>
+          <p:nvPr/>
+        </p:nvPicPr>
+        <p:blipFill>
+          <a:blip r:embed="rId2"/>
+          <a:stretch>
+            <a:fillRect/>
+          </a:stretch>
+        </p:blipFill>
+        <p:spPr>
+          <a:xfrm>
+            <a:off x="5270500" y="1401762"/>
+            <a:ext cx="1651000" cy="1651000"/>
+          </a:xfrm>
+          <a:prstGeom prst="rect">
+            <a:avLst/>
+          </a:prstGeom>
+        </p:spPr>
+      </p:pic>
+      <p:sp>
+        <p:nvSpPr>
+          <p:cNvPr id="3" name="TextBox 2"/>
+          <p:cNvSpPr txBox="1"/>
+          <p:nvPr/>
+        </p:nvSpPr>
+        <p:spPr>
+          <a:xfrm>
+            <a:off x="5217517" y="3281362"/>
             <a:ext cx="1809675" cy="355600"/>
           </a:xfrm>
           <a:prstGeom prst="rect">
@@ -24511,13 +24583,13 @@
       </p:sp>
       <p:sp>
         <p:nvSpPr>
-          <p:cNvPr id="3" name="TextBox 2"/>
-          <p:cNvSpPr txBox="1"/>
-          <p:nvPr/>
-        </p:nvSpPr>
-        <p:spPr>
-          <a:xfrm>
-            <a:off x="3589933" y="2925762"/>
+          <p:cNvPr id="4" name="TextBox 3"/>
+          <p:cNvSpPr txBox="1"/>
+          <p:nvPr/>
+        </p:nvSpPr>
+        <p:spPr>
+          <a:xfrm>
+            <a:off x="3589933" y="3865562"/>
             <a:ext cx="5162498" cy="1095375"/>
           </a:xfrm>
           <a:prstGeom prst="rect">
@@ -24550,13 +24622,13 @@
       </p:sp>
       <p:sp>
         <p:nvSpPr>
-          <p:cNvPr id="4" name="TextBox 3"/>
-          <p:cNvSpPr txBox="1"/>
-          <p:nvPr/>
-        </p:nvSpPr>
-        <p:spPr>
-          <a:xfrm>
-            <a:off x="3269655" y="4300538"/>
+          <p:cNvPr id="5" name="TextBox 4"/>
+          <p:cNvSpPr txBox="1"/>
+          <p:nvPr/>
+        </p:nvSpPr>
+        <p:spPr>
+          <a:xfrm>
+            <a:off x="3269655" y="5189538"/>
             <a:ext cx="5822271" cy="266700"/>
           </a:xfrm>
           <a:prstGeom prst="rect">
@@ -24589,7 +24661,7 @@
       </p:sp>
       <p:sp>
         <p:nvSpPr>
-          <p:cNvPr id="5" name="TextBox 4"/>
+          <p:cNvPr id="6" name="TextBox 5"/>
           <p:cNvSpPr txBox="1"/>
           <p:nvPr/>
         </p:nvSpPr>
@@ -24704,7 +24776,7 @@
         </p:nvSpPr>
         <p:spPr>
           <a:xfrm>
-            <a:off x="1168400" y="1105892"/>
+            <a:off x="1168400" y="1093192"/>
             <a:ext cx="10569448" cy="452735"/>
           </a:xfrm>
           <a:prstGeom prst="rect">
@@ -24873,7 +24945,7 @@
         </p:blipFill>
         <p:spPr>
           <a:xfrm>
-            <a:off x="5537200" y="1787227"/>
+            <a:off x="5537200" y="1774527"/>
             <a:ext cx="5892800" cy="3314700"/>
           </a:xfrm>
           <a:prstGeom prst="rect">
@@ -24889,7 +24961,7 @@
         </p:nvSpPr>
         <p:spPr>
           <a:xfrm>
-            <a:off x="1168400" y="5330527"/>
+            <a:off x="1168400" y="5343227"/>
             <a:ext cx="10569448" cy="231080"/>
           </a:xfrm>
           <a:prstGeom prst="rect">

</xml_diff>

<commit_message>
Foto da palestrante só no slide 2
Co-Authored-By: Claude Opus 5.5 <noreply@anthropic.com>
Claude-Session: https://claude.ai/code/session_013ZYQJsTZixhcpCnj3mHGtq
</commit_message>
<xml_diff>
--- a/workshop-aba-tea-lacc/apresentacao/Apresentacao_Workshop_ABA_TEA.pptx
+++ b/workshop-aba-tea-lacc/apresentacao/Apresentacao_Workshop_ABA_TEA.pptx
@@ -7904,30 +7904,45 @@
           </a:p>
         </p:txBody>
       </p:sp>
-      <p:pic>
-        <p:nvPicPr>
-          <p:cNvPr id="3" name="Picture 2" descr="foto_circulo_pptx.png"/>
-          <p:cNvPicPr>
-            <a:picLocks noChangeAspect="1"/>
-          </p:cNvPicPr>
-          <p:nvPr/>
-        </p:nvPicPr>
-        <p:blipFill>
-          <a:blip r:embed="rId2"/>
-          <a:stretch>
-            <a:fillRect/>
-          </a:stretch>
-        </p:blipFill>
-        <p:spPr>
-          <a:xfrm>
-            <a:off x="8445500" y="1905000"/>
-            <a:ext cx="2794000" cy="2794000"/>
-          </a:xfrm>
-          <a:prstGeom prst="rect">
-            <a:avLst/>
-          </a:prstGeom>
-        </p:spPr>
-      </p:pic>
+      <p:sp>
+        <p:nvSpPr>
+          <p:cNvPr id="3" name="TextBox 2"/>
+          <p:cNvSpPr txBox="1"/>
+          <p:nvPr/>
+        </p:nvSpPr>
+        <p:spPr>
+          <a:xfrm>
+            <a:off x="1016000" y="1723430"/>
+            <a:ext cx="10464800" cy="247650"/>
+          </a:xfrm>
+          <a:prstGeom prst="rect">
+            <a:avLst/>
+          </a:prstGeom>
+          <a:noFill/>
+        </p:spPr>
+        <p:txBody>
+          <a:bodyPr wrap="square" lIns="0" rIns="0" tIns="0" bIns="0" anchor="t">
+            <a:noAutofit/>
+          </a:bodyPr>
+          <a:lstStyle/>
+          <a:p>
+            <a:pPr algn="l">
+              <a:lnSpc>
+                <a:spcPct val="98000"/>
+              </a:lnSpc>
+            </a:pPr>
+            <a:r>
+              <a:rPr sz="1600" b="0" i="0">
+                <a:solidFill>
+                  <a:srgbClr val="9FD3D8"/>
+                </a:solidFill>
+                <a:latin typeface="Montserrat"/>
+              </a:rPr>
+              <a:t>Liga Acadêmica Cognitivo-Comportamental (LACC)</a:t>
+            </a:r>
+          </a:p>
+        </p:txBody>
+      </p:sp>
       <p:sp>
         <p:nvSpPr>
           <p:cNvPr id="4" name="TextBox 3"/>
@@ -7936,8 +7951,8 @@
         </p:nvSpPr>
         <p:spPr>
           <a:xfrm>
-            <a:off x="1016000" y="1723430"/>
-            <a:ext cx="7456170" cy="247650"/>
+            <a:off x="1016000" y="2148880"/>
+            <a:ext cx="10464800" cy="889000"/>
           </a:xfrm>
           <a:prstGeom prst="rect">
             <a:avLst/>
@@ -7952,31 +7967,70 @@
           <a:p>
             <a:pPr algn="l">
               <a:lnSpc>
+                <a:spcPct val="82000"/>
+              </a:lnSpc>
+            </a:pPr>
+            <a:r>
+              <a:rPr sz="7000" b="1" i="0">
+                <a:solidFill>
+                  <a:srgbClr val="FFFFFF"/>
+                </a:solidFill>
+                <a:latin typeface="Montserrat"/>
+              </a:rPr>
+              <a:t>ABA e TEA</a:t>
+            </a:r>
+          </a:p>
+        </p:txBody>
+      </p:sp>
+      <p:sp>
+        <p:nvSpPr>
+          <p:cNvPr id="5" name="TextBox 4"/>
+          <p:cNvSpPr txBox="1"/>
+          <p:nvPr/>
+        </p:nvSpPr>
+        <p:spPr>
+          <a:xfrm>
+            <a:off x="1016000" y="3215680"/>
+            <a:ext cx="10464800" cy="426641"/>
+          </a:xfrm>
+          <a:prstGeom prst="rect">
+            <a:avLst/>
+          </a:prstGeom>
+          <a:noFill/>
+        </p:spPr>
+        <p:txBody>
+          <a:bodyPr wrap="square" lIns="0" rIns="0" tIns="0" bIns="0" anchor="t">
+            <a:noAutofit/>
+          </a:bodyPr>
+          <a:lstStyle/>
+          <a:p>
+            <a:pPr algn="l">
+              <a:lnSpc>
                 <a:spcPct val="98000"/>
               </a:lnSpc>
             </a:pPr>
             <a:r>
-              <a:rPr sz="1600" b="0" i="0">
-                <a:solidFill>
-                  <a:srgbClr val="9FD3D8"/>
-                </a:solidFill>
-                <a:latin typeface="Montserrat"/>
-              </a:rPr>
-              <a:t>Liga Acadêmica Cognitivo-Comportamental (LACC)</a:t>
-            </a:r>
-          </a:p>
-        </p:txBody>
-      </p:sp>
-      <p:sp>
-        <p:nvSpPr>
-          <p:cNvPr id="5" name="TextBox 4"/>
-          <p:cNvSpPr txBox="1"/>
-          <p:nvPr/>
-        </p:nvSpPr>
-        <p:spPr>
-          <a:xfrm>
-            <a:off x="1016000" y="2148880"/>
-            <a:ext cx="7456170" cy="889000"/>
+              <a:rPr sz="2800" b="0" i="0">
+                <a:solidFill>
+                  <a:srgbClr val="E6ECF2"/>
+                </a:solidFill>
+                <a:latin typeface="Montserrat"/>
+              </a:rPr>
+              <a:t>da análise funcional à decisão clínica</a:t>
+            </a:r>
+          </a:p>
+        </p:txBody>
+      </p:sp>
+      <p:sp>
+        <p:nvSpPr>
+          <p:cNvPr id="6" name="TextBox 5"/>
+          <p:cNvSpPr txBox="1"/>
+          <p:nvPr/>
+        </p:nvSpPr>
+        <p:spPr>
+          <a:xfrm>
+            <a:off x="1016000" y="4378920"/>
+            <a:ext cx="10464800" cy="330200"/>
           </a:xfrm>
           <a:prstGeom prst="rect">
             <a:avLst/>
@@ -7991,56 +8045,17 @@
           <a:p>
             <a:pPr algn="l">
               <a:lnSpc>
-                <a:spcPct val="82000"/>
-              </a:lnSpc>
-            </a:pPr>
-            <a:r>
-              <a:rPr sz="7000" b="1" i="0">
+                <a:spcPct val="98000"/>
+              </a:lnSpc>
+            </a:pPr>
+            <a:r>
+              <a:rPr sz="2100" b="1" i="0">
                 <a:solidFill>
                   <a:srgbClr val="FFFFFF"/>
                 </a:solidFill>
                 <a:latin typeface="Montserrat"/>
               </a:rPr>
-              <a:t>ABA e TEA</a:t>
-            </a:r>
-          </a:p>
-        </p:txBody>
-      </p:sp>
-      <p:sp>
-        <p:nvSpPr>
-          <p:cNvPr id="6" name="TextBox 5"/>
-          <p:cNvSpPr txBox="1"/>
-          <p:nvPr/>
-        </p:nvSpPr>
-        <p:spPr>
-          <a:xfrm>
-            <a:off x="1016000" y="3215680"/>
-            <a:ext cx="7456170" cy="426641"/>
-          </a:xfrm>
-          <a:prstGeom prst="rect">
-            <a:avLst/>
-          </a:prstGeom>
-          <a:noFill/>
-        </p:spPr>
-        <p:txBody>
-          <a:bodyPr wrap="square" lIns="0" rIns="0" tIns="0" bIns="0" anchor="t">
-            <a:noAutofit/>
-          </a:bodyPr>
-          <a:lstStyle/>
-          <a:p>
-            <a:pPr algn="l">
-              <a:lnSpc>
-                <a:spcPct val="98000"/>
-              </a:lnSpc>
-            </a:pPr>
-            <a:r>
-              <a:rPr sz="2800" b="0" i="0">
-                <a:solidFill>
-                  <a:srgbClr val="E6ECF2"/>
-                </a:solidFill>
-                <a:latin typeface="Montserrat"/>
-              </a:rPr>
-              <a:t>da análise funcional à decisão clínica</a:t>
+              <a:t>Betina Binatti</a:t>
             </a:r>
           </a:p>
         </p:txBody>
@@ -8053,47 +8068,8 @@
         </p:nvSpPr>
         <p:spPr>
           <a:xfrm>
-            <a:off x="1016000" y="4378920"/>
-            <a:ext cx="7456170" cy="330200"/>
-          </a:xfrm>
-          <a:prstGeom prst="rect">
-            <a:avLst/>
-          </a:prstGeom>
-          <a:noFill/>
-        </p:spPr>
-        <p:txBody>
-          <a:bodyPr wrap="square" lIns="0" rIns="0" tIns="0" bIns="0" anchor="t">
-            <a:noAutofit/>
-          </a:bodyPr>
-          <a:lstStyle/>
-          <a:p>
-            <a:pPr algn="l">
-              <a:lnSpc>
-                <a:spcPct val="98000"/>
-              </a:lnSpc>
-            </a:pPr>
-            <a:r>
-              <a:rPr sz="2100" b="1" i="0">
-                <a:solidFill>
-                  <a:srgbClr val="FFFFFF"/>
-                </a:solidFill>
-                <a:latin typeface="Montserrat"/>
-              </a:rPr>
-              <a:t>Betina Binatti</a:t>
-            </a:r>
-          </a:p>
-        </p:txBody>
-      </p:sp>
-      <p:sp>
-        <p:nvSpPr>
-          <p:cNvPr id="8" name="TextBox 7"/>
-          <p:cNvSpPr txBox="1"/>
-          <p:nvPr/>
-        </p:nvSpPr>
-        <p:spPr>
-          <a:xfrm>
             <a:off x="1016000" y="4886920"/>
-            <a:ext cx="7456170" cy="247650"/>
+            <a:ext cx="10464800" cy="247650"/>
           </a:xfrm>
           <a:prstGeom prst="rect">
             <a:avLst/>
@@ -24518,30 +24494,45 @@
         <p:nvPr/>
       </p:nvGrpSpPr>
       <p:grpSpPr/>
-      <p:pic>
-        <p:nvPicPr>
-          <p:cNvPr id="2" name="Picture 1" descr="foto_circulo_pptx.png"/>
-          <p:cNvPicPr>
-            <a:picLocks noChangeAspect="1"/>
-          </p:cNvPicPr>
-          <p:nvPr/>
-        </p:nvPicPr>
-        <p:blipFill>
-          <a:blip r:embed="rId2"/>
-          <a:stretch>
-            <a:fillRect/>
-          </a:stretch>
-        </p:blipFill>
-        <p:spPr>
-          <a:xfrm>
-            <a:off x="5270500" y="1401762"/>
-            <a:ext cx="1651000" cy="1651000"/>
-          </a:xfrm>
-          <a:prstGeom prst="rect">
-            <a:avLst/>
-          </a:prstGeom>
-        </p:spPr>
-      </p:pic>
+      <p:sp>
+        <p:nvSpPr>
+          <p:cNvPr id="2" name="TextBox 1"/>
+          <p:cNvSpPr txBox="1"/>
+          <p:nvPr/>
+        </p:nvSpPr>
+        <p:spPr>
+          <a:xfrm>
+            <a:off x="5217517" y="2290762"/>
+            <a:ext cx="1809675" cy="355600"/>
+          </a:xfrm>
+          <a:prstGeom prst="rect">
+            <a:avLst/>
+          </a:prstGeom>
+          <a:noFill/>
+        </p:spPr>
+        <p:txBody>
+          <a:bodyPr wrap="square" lIns="0" rIns="0" tIns="0" bIns="0" anchor="t">
+            <a:noAutofit/>
+          </a:bodyPr>
+          <a:lstStyle/>
+          <a:p>
+            <a:pPr algn="ctr">
+              <a:lnSpc>
+                <a:spcPct val="115000"/>
+              </a:lnSpc>
+            </a:pPr>
+            <a:r>
+              <a:rPr sz="2000" b="0" i="0">
+                <a:solidFill>
+                  <a:srgbClr val="D8E1EA"/>
+                </a:solidFill>
+                <a:latin typeface="Montserrat"/>
+              </a:rPr>
+              <a:t>Betina Binatti</a:t>
+            </a:r>
+          </a:p>
+        </p:txBody>
+      </p:sp>
       <p:sp>
         <p:nvSpPr>
           <p:cNvPr id="3" name="TextBox 2"/>
@@ -24550,8 +24541,8 @@
         </p:nvSpPr>
         <p:spPr>
           <a:xfrm>
-            <a:off x="5217517" y="3281362"/>
-            <a:ext cx="1809675" cy="355600"/>
+            <a:off x="3589933" y="2925762"/>
+            <a:ext cx="5162498" cy="1095375"/>
           </a:xfrm>
           <a:prstGeom prst="rect">
             <a:avLst/>
@@ -24566,56 +24557,56 @@
           <a:p>
             <a:pPr algn="ctr">
               <a:lnSpc>
+                <a:spcPct val="94000"/>
+              </a:lnSpc>
+            </a:pPr>
+            <a:r>
+              <a:rPr sz="7500" b="1" i="0">
+                <a:solidFill>
+                  <a:srgbClr val="FFFFFF"/>
+                </a:solidFill>
+                <a:latin typeface="Montserrat"/>
+              </a:rPr>
+              <a:t>Obrigada!</a:t>
+            </a:r>
+          </a:p>
+        </p:txBody>
+      </p:sp>
+      <p:sp>
+        <p:nvSpPr>
+          <p:cNvPr id="4" name="TextBox 3"/>
+          <p:cNvSpPr txBox="1"/>
+          <p:nvPr/>
+        </p:nvSpPr>
+        <p:spPr>
+          <a:xfrm>
+            <a:off x="3269655" y="4300538"/>
+            <a:ext cx="5822271" cy="266700"/>
+          </a:xfrm>
+          <a:prstGeom prst="rect">
+            <a:avLst/>
+          </a:prstGeom>
+          <a:noFill/>
+        </p:spPr>
+        <p:txBody>
+          <a:bodyPr wrap="square" lIns="0" rIns="0" tIns="0" bIns="0" anchor="t">
+            <a:noAutofit/>
+          </a:bodyPr>
+          <a:lstStyle/>
+          <a:p>
+            <a:pPr algn="ctr">
+              <a:lnSpc>
                 <a:spcPct val="115000"/>
               </a:lnSpc>
             </a:pPr>
             <a:r>
-              <a:rPr sz="2000" b="0" i="0">
-                <a:solidFill>
-                  <a:srgbClr val="D8E1EA"/>
-                </a:solidFill>
-                <a:latin typeface="Montserrat"/>
-              </a:rPr>
-              <a:t>Betina Binatti</a:t>
-            </a:r>
-          </a:p>
-        </p:txBody>
-      </p:sp>
-      <p:sp>
-        <p:nvSpPr>
-          <p:cNvPr id="4" name="TextBox 3"/>
-          <p:cNvSpPr txBox="1"/>
-          <p:nvPr/>
-        </p:nvSpPr>
-        <p:spPr>
-          <a:xfrm>
-            <a:off x="3589933" y="3865562"/>
-            <a:ext cx="5162498" cy="1095375"/>
-          </a:xfrm>
-          <a:prstGeom prst="rect">
-            <a:avLst/>
-          </a:prstGeom>
-          <a:noFill/>
-        </p:spPr>
-        <p:txBody>
-          <a:bodyPr wrap="square" lIns="0" rIns="0" tIns="0" bIns="0" anchor="t">
-            <a:noAutofit/>
-          </a:bodyPr>
-          <a:lstStyle/>
-          <a:p>
-            <a:pPr algn="ctr">
-              <a:lnSpc>
-                <a:spcPct val="94000"/>
-              </a:lnSpc>
-            </a:pPr>
-            <a:r>
-              <a:rPr sz="7500" b="1" i="0">
-                <a:solidFill>
-                  <a:srgbClr val="FFFFFF"/>
-                </a:solidFill>
-                <a:latin typeface="Montserrat"/>
-              </a:rPr>
-              <a:t>Obrigada!</a:t>
+              <a:rPr sz="1500" b="0" i="1">
+                <a:solidFill>
+                  <a:srgbClr val="9FD3D8"/>
+                </a:solidFill>
+                <a:latin typeface="Montserrat"/>
+              </a:rPr>
+              <a:t>Workshop ABA e TEA, LACC, PUCRS, 24 de outubro de 2026</a:t>
             </a:r>
           </a:p>
         </p:txBody>
@@ -24623,45 +24614,6 @@
       <p:sp>
         <p:nvSpPr>
           <p:cNvPr id="5" name="TextBox 4"/>
-          <p:cNvSpPr txBox="1"/>
-          <p:nvPr/>
-        </p:nvSpPr>
-        <p:spPr>
-          <a:xfrm>
-            <a:off x="3269655" y="5189538"/>
-            <a:ext cx="5822271" cy="266700"/>
-          </a:xfrm>
-          <a:prstGeom prst="rect">
-            <a:avLst/>
-          </a:prstGeom>
-          <a:noFill/>
-        </p:spPr>
-        <p:txBody>
-          <a:bodyPr wrap="square" lIns="0" rIns="0" tIns="0" bIns="0" anchor="t">
-            <a:noAutofit/>
-          </a:bodyPr>
-          <a:lstStyle/>
-          <a:p>
-            <a:pPr algn="ctr">
-              <a:lnSpc>
-                <a:spcPct val="115000"/>
-              </a:lnSpc>
-            </a:pPr>
-            <a:r>
-              <a:rPr sz="1500" b="0" i="1">
-                <a:solidFill>
-                  <a:srgbClr val="9FD3D8"/>
-                </a:solidFill>
-                <a:latin typeface="Montserrat"/>
-              </a:rPr>
-              <a:t>Workshop ABA e TEA, LACC, PUCRS, 24 de outubro de 2026</a:t>
-            </a:r>
-          </a:p>
-        </p:txBody>
-      </p:sp>
-      <p:sp>
-        <p:nvSpPr>
-          <p:cNvPr id="6" name="TextBox 5"/>
           <p:cNvSpPr txBox="1"/>
           <p:nvPr/>
         </p:nvSpPr>

</xml_diff>

<commit_message>
Slide 7: nota sobre DSM-IV e DSM-5; slide 8: níveis de suporte
Co-Authored-By: Claude Opus 5.5 <noreply@anthropic.com>
Claude-Session: https://claude.ai/code/session_013ZYQJsTZixhcpCnj3mHGtq
</commit_message>
<xml_diff>
--- a/workshop-aba-tea-lacc/apresentacao/Apresentacao_Workshop_ABA_TEA.pptx
+++ b/workshop-aba-tea-lacc/apresentacao/Apresentacao_Workshop_ABA_TEA.pptx
@@ -4706,7 +4706,7 @@
           <a:lstStyle/>
           <a:p>
             <a:r>
-              <a:t>O manual usa o termo "déficits"; o slide usa "diferenças" por coerência com a linguagem do workshop. Ao falar, mencionar que o texto diagnóstico usa "déficits". No domínio B, citar as quatro formas (movimentos, fala ou uso de objetos estereotipados; insistência na mesmice; interesses restritos e intensos; hiper ou hiporreatividade sensorial), das quais pelo menos duas são necessárias. Conferir a redação na edição em uso. Tempo: 3 min (início do Bloco 1, 9h40).</a:t>
+              <a:t>O manual usa o termo "déficits"; o slide usa "diferenças" por coerência com a linguagem do workshop. Ao falar, mencionar que o texto diagnóstico usa "déficits". No domínio B, citar as quatro formas (movimentos, fala ou uso de objetos estereotipados; insistência na mesmice; interesses restritos e intensos; hiper ou hiporreatividade sensorial), das quais pelo menos duas são necessárias. Se perguntarem "só duas áreas?": sim. No DSM-IV havia a tríade (interação social, comunicação, comportamentos repetitivos); o DSM-5 juntou interação social e comunicação em um domínio, e o atraso de linguagem passou a ser especificador. Os outros critérios (C, D e E) são: sinais no início do desenvolvimento, prejuízo significativo e não ser melhor explicado por deficiência intelectual. Conferir a redação na edição em uso. Tempo: 3 min (início do Bloco 1, 9h40).</a:t>
             </a:r>
           </a:p>
         </p:txBody>
@@ -4776,7 +4776,7 @@
           <a:lstStyle/>
           <a:p>
             <a:r>
-              <a:t>Os níveis descrevem necessidade de apoio, não "grau de autismo" nem valor da pessoa. O nível pode variar entre domínios e ao longo do tempo. Conferir a nomenclatura exata da tradução em uso. Tempo: 2 min.</a:t>
+              <a:t>Usamos "níveis de suporte" porque descrevem o suporte necessário, não "grau de autismo" nem valor da pessoa; o nome oficial no DSM-5-TR é "níveis de gravidade" (citado no slide para não parecer erro). O nível pode variar entre domínios e ao longo do tempo. Conferir a nomenclatura exata da tradução em uso. Tempo: 2 min.</a:t>
             </a:r>
           </a:p>
         </p:txBody>
@@ -29485,7 +29485,7 @@
         </p:nvSpPr>
         <p:spPr>
           <a:xfrm>
-            <a:off x="1168400" y="1161752"/>
+            <a:off x="1168400" y="977602"/>
             <a:ext cx="10307828" cy="963811"/>
           </a:xfrm>
           <a:prstGeom prst="rect">
@@ -29524,7 +29524,7 @@
         </p:nvSpPr>
         <p:spPr>
           <a:xfrm>
-            <a:off x="1168400" y="2455763"/>
+            <a:off x="1168400" y="2195413"/>
             <a:ext cx="4839970" cy="319980"/>
           </a:xfrm>
           <a:prstGeom prst="rect">
@@ -29563,7 +29563,7 @@
         </p:nvSpPr>
         <p:spPr>
           <a:xfrm>
-            <a:off x="1168400" y="2864644"/>
+            <a:off x="1168400" y="2604294"/>
             <a:ext cx="4839970" cy="675481"/>
           </a:xfrm>
           <a:prstGeom prst="rect">
@@ -29602,7 +29602,7 @@
         </p:nvSpPr>
         <p:spPr>
           <a:xfrm>
-            <a:off x="6477000" y="2455763"/>
+            <a:off x="6477000" y="2195413"/>
             <a:ext cx="4839970" cy="319980"/>
           </a:xfrm>
           <a:prstGeom prst="rect">
@@ -29641,7 +29641,7 @@
         </p:nvSpPr>
         <p:spPr>
           <a:xfrm>
-            <a:off x="6477000" y="2864644"/>
+            <a:off x="6477000" y="2604294"/>
             <a:ext cx="4839970" cy="1350962"/>
           </a:xfrm>
           <a:prstGeom prst="rect">
@@ -29680,7 +29680,7 @@
         </p:nvSpPr>
         <p:spPr>
           <a:xfrm>
-            <a:off x="1168400" y="4545806"/>
+            <a:off x="1168400" y="4209256"/>
             <a:ext cx="10307828" cy="959941"/>
           </a:xfrm>
           <a:prstGeom prst="rect">
@@ -29714,6 +29714,45 @@
       <p:sp>
         <p:nvSpPr>
           <p:cNvPr id="9" name="TextBox 8"/>
+          <p:cNvSpPr txBox="1"/>
+          <p:nvPr/>
+        </p:nvSpPr>
+        <p:spPr>
+          <a:xfrm>
+            <a:off x="1168400" y="5423198"/>
+            <a:ext cx="10307828" cy="266700"/>
+          </a:xfrm>
+          <a:prstGeom prst="rect">
+            <a:avLst/>
+          </a:prstGeom>
+          <a:noFill/>
+        </p:spPr>
+        <p:txBody>
+          <a:bodyPr wrap="square" lIns="0" rIns="0" tIns="0" bIns="0" anchor="t">
+            <a:noAutofit/>
+          </a:bodyPr>
+          <a:lstStyle/>
+          <a:p>
+            <a:pPr algn="l">
+              <a:lnSpc>
+                <a:spcPct val="115000"/>
+              </a:lnSpc>
+            </a:pPr>
+            <a:r>
+              <a:rPr sz="1500" b="0" i="1">
+                <a:solidFill>
+                  <a:srgbClr val="66717F"/>
+                </a:solidFill>
+                <a:latin typeface="Montserrat"/>
+              </a:rPr>
+              <a:t>No DSM-IV eram três áreas. Desde o DSM-5, comunicação e interação social formam um único domínio.</a:t>
+            </a:r>
+          </a:p>
+        </p:txBody>
+      </p:sp>
+      <p:sp>
+        <p:nvSpPr>
+          <p:cNvPr id="10" name="TextBox 9"/>
           <p:cNvSpPr txBox="1"/>
           <p:nvPr/>
         </p:nvSpPr>
@@ -29752,7 +29791,7 @@
       </p:sp>
       <p:sp>
         <p:nvSpPr>
-          <p:cNvPr id="10" name="TextBox 9"/>
+          <p:cNvPr id="11" name="TextBox 10"/>
           <p:cNvSpPr txBox="1"/>
           <p:nvPr/>
         </p:nvSpPr>
@@ -29867,7 +29906,7 @@
         </p:nvSpPr>
         <p:spPr>
           <a:xfrm>
-            <a:off x="1168400" y="1134467"/>
+            <a:off x="1168400" y="1001117"/>
             <a:ext cx="10307828" cy="481905"/>
           </a:xfrm>
           <a:prstGeom prst="rect">
@@ -29893,7 +29932,7 @@
                 </a:solidFill>
                 <a:latin typeface="Montserrat"/>
               </a:rPr>
-              <a:t>Especificadores e níveis de gravidade</a:t>
+              <a:t>Especificadores e níveis de suporte</a:t>
             </a:r>
           </a:p>
         </p:txBody>
@@ -29906,7 +29945,7 @@
         </p:nvSpPr>
         <p:spPr>
           <a:xfrm>
-            <a:off x="1168400" y="1870373"/>
+            <a:off x="1168400" y="1737023"/>
             <a:ext cx="10307828" cy="906661"/>
           </a:xfrm>
           <a:prstGeom prst="rect">
@@ -29955,7 +29994,7 @@
           <p:nvPr/>
         </p:nvGraphicFramePr>
         <p:xfrm>
-          <a:off x="1168400" y="3031034"/>
+          <a:off x="1168400" y="2897684"/>
           <a:ext cx="10007600" cy="1981200"/>
         </p:xfrm>
         <a:graphic>
@@ -30013,7 +30052,7 @@
                           </a:solidFill>
                           <a:latin typeface="Montserrat"/>
                         </a:rPr>
-                        <a:t>Necessidade de apoio</a:t>
+                        <a:t>Suporte necessário</a:t>
                       </a:r>
                     </a:p>
                   </a:txBody>
@@ -30069,7 +30108,7 @@
                           </a:solidFill>
                           <a:latin typeface="Montserrat"/>
                         </a:rPr>
-                        <a:t>Exige apoio</a:t>
+                        <a:t>Exige suporte</a:t>
                       </a:r>
                     </a:p>
                   </a:txBody>
@@ -30125,7 +30164,7 @@
                           </a:solidFill>
                           <a:latin typeface="Montserrat"/>
                         </a:rPr>
-                        <a:t>Exige apoio substancial</a:t>
+                        <a:t>Exige suporte substancial</a:t>
                       </a:r>
                     </a:p>
                   </a:txBody>
@@ -30181,7 +30220,7 @@
                           </a:solidFill>
                           <a:latin typeface="Montserrat"/>
                         </a:rPr>
-                        <a:t>Exige apoio muito substancial</a:t>
+                        <a:t>Exige suporte muito substancial</a:t>
                       </a:r>
                     </a:p>
                   </a:txBody>
@@ -30204,8 +30243,8 @@
         </p:nvSpPr>
         <p:spPr>
           <a:xfrm>
-            <a:off x="1168400" y="5266234"/>
-            <a:ext cx="10307828" cy="266700"/>
+            <a:off x="1168400" y="5132884"/>
+            <a:ext cx="10307828" cy="533400"/>
           </a:xfrm>
           <a:prstGeom prst="rect">
             <a:avLst/>
@@ -30230,7 +30269,7 @@
                 </a:solidFill>
                 <a:latin typeface="Montserrat"/>
               </a:rPr>
-              <a:t>Os níveis são definidos para cada domínio e descrevem necessidade de apoio, não “grau de autismo”.</a:t>
+              <a:t>Os níveis são definidos para cada domínio e descrevem o suporte necessário, não um “grau de autismo”. No texto do DSM-5-TR, o nome oficial é “níveis de gravidade”.</a:t>
             </a:r>
           </a:p>
         </p:txBody>

</xml_diff>

<commit_message>
Slide 19: reforçamento automático explicado como a função chamada de sensorial
Co-Authored-By: Claude Opus 5.5 <noreply@anthropic.com>
Claude-Session: https://claude.ai/code/session_013ZYQJsTZixhcpCnj3mHGtq
</commit_message>
<xml_diff>
--- a/workshop-aba-tea-lacc/apresentacao/Apresentacao_Workshop_ABA_TEA.pptx
+++ b/workshop-aba-tea-lacc/apresentacao/Apresentacao_Workshop_ABA_TEA.pptx
@@ -1268,7 +1268,7 @@
           <a:lstStyle/>
           <a:p>
             <a:r>
-              <a:t>A revisão de Hanley et al. (2003) mostra como essas categorias foram estudadas em centenas de análises funcionais. Hanley et al. (2014) ilustram funções sintetizadas (mais de uma consequência ao mesmo tempo). Tempo: 3 min.</a:t>
+              <a:t>A revisão de Hanley et al. (2003) mostra como essas categorias foram estudadas em centenas de análises funcionais. Hanley et al. (2014) ilustram funções sintetizadas (mais de uma consequência ao mesmo tempo). Se perguntarem pela função "sensorial": é o item 4. Na literatura atual se prefere "reforçamento automático", porque nem sempre é estimulação sensorial: pode ser alívio de dor ou desconforto (reforçamento automático negativo). O que define é que a consequência não depende de outra pessoa. Tempo: 3 min.</a:t>
             </a:r>
           </a:p>
         </p:txBody>
@@ -11974,7 +11974,7 @@
         </p:nvSpPr>
         <p:spPr>
           <a:xfrm>
-            <a:off x="1168400" y="1149152"/>
+            <a:off x="1168400" y="1132284"/>
             <a:ext cx="10307828" cy="481905"/>
           </a:xfrm>
           <a:prstGeom prst="rect">
@@ -12013,8 +12013,8 @@
         </p:nvSpPr>
         <p:spPr>
           <a:xfrm>
-            <a:off x="1168400" y="1961257"/>
-            <a:ext cx="10307828" cy="2286000"/>
+            <a:off x="1168400" y="1944390"/>
+            <a:ext cx="10307828" cy="2319734"/>
           </a:xfrm>
           <a:prstGeom prst="rect">
             <a:avLst/>
@@ -12029,12 +12029,12 @@
           <a:p>
             <a:pPr algn="l" marL="279400" indent="-279400">
               <a:lnSpc>
-                <a:spcPct val="123000"/>
+                <a:spcPct val="119000"/>
               </a:lnSpc>
               <a:buAutoNum type="arabicPeriod" startAt="1"/>
             </a:pPr>
             <a:r>
-              <a:rPr sz="2000" b="0" i="0">
+              <a:rPr sz="1800" b="0" i="0">
                 <a:solidFill>
                   <a:srgbClr val="2E3A4A"/>
                 </a:solidFill>
@@ -12046,12 +12046,12 @@
           <a:p>
             <a:pPr algn="l" marL="279400" indent="-279400">
               <a:lnSpc>
-                <a:spcPct val="123000"/>
+                <a:spcPct val="119000"/>
               </a:lnSpc>
               <a:buAutoNum type="arabicPeriod" startAt="1"/>
             </a:pPr>
             <a:r>
-              <a:rPr sz="2000" b="0" i="0">
+              <a:rPr sz="1800" b="0" i="0">
                 <a:solidFill>
                   <a:srgbClr val="2E3A4A"/>
                 </a:solidFill>
@@ -12063,12 +12063,12 @@
           <a:p>
             <a:pPr algn="l" marL="279400" indent="-279400">
               <a:lnSpc>
-                <a:spcPct val="123000"/>
+                <a:spcPct val="119000"/>
               </a:lnSpc>
               <a:buAutoNum type="arabicPeriod" startAt="1"/>
             </a:pPr>
             <a:r>
-              <a:rPr sz="2000" b="0" i="0">
+              <a:rPr sz="1800" b="0" i="0">
                 <a:solidFill>
                   <a:srgbClr val="2E3A4A"/>
                 </a:solidFill>
@@ -12080,18 +12080,18 @@
           <a:p>
             <a:pPr algn="l" marL="279400" indent="-279400">
               <a:lnSpc>
-                <a:spcPct val="123000"/>
+                <a:spcPct val="119000"/>
               </a:lnSpc>
               <a:buAutoNum type="arabicPeriod" startAt="1"/>
             </a:pPr>
             <a:r>
-              <a:rPr sz="2000" b="0" i="0">
+              <a:rPr sz="1800" b="0" i="0">
                 <a:solidFill>
                   <a:srgbClr val="2E3A4A"/>
                 </a:solidFill>
                 <a:latin typeface="Montserrat"/>
               </a:rPr>
-              <a:t>Reforçamento automático: o próprio comportamento produz a consequência</a:t>
+              <a:t>Reforçamento automático (a função que muitos chamam de “sensorial”): o próprio comportamento produz a consequência, como uma sensação agradável ou o alívio de um desconforto</a:t>
             </a:r>
           </a:p>
         </p:txBody>
@@ -12104,7 +12104,7 @@
         </p:nvSpPr>
         <p:spPr>
           <a:xfrm>
-            <a:off x="1168400" y="4577457"/>
+            <a:off x="1168400" y="4594324"/>
             <a:ext cx="10307828" cy="940891"/>
           </a:xfrm>
           <a:prstGeom prst="rect">

</xml_diff>

<commit_message>
Slides 44 e 45 reescritos em linguagem simples; termos das explicações padronizados
Co-Authored-By: Claude Opus 5.5 <noreply@anthropic.com>
Claude-Session: https://claude.ai/code/session_013ZYQJsTZixhcpCnj3mHGtq
</commit_message>
<xml_diff>
--- a/workshop-aba-tea-lacc/apresentacao/Apresentacao_Workshop_ABA_TEA.pptx
+++ b/workshop-aba-tea-lacc/apresentacao/Apresentacao_Workshop_ABA_TEA.pptx
@@ -3282,7 +3282,7 @@
           <a:lstStyle/>
           <a:p>
             <a:r>
-              <a:t>Slide de respostas: mostrar depois que a turma responder.</a:t>
+              <a:t>Slide de respostas: mostrar depois que a turma responder. Ler linha por linha: explicação, o que a favor, o que contra. Destacar que o lanche é o dado que mais ajuda a decidir.</a:t>
             </a:r>
           </a:p>
         </p:txBody>
@@ -3352,7 +3352,7 @@
           <a:lstStyle/>
           <a:p>
             <a:r>
-              <a:t>Slide de respostas: mostrar depois que a turma responder.</a:t>
+              <a:t>Slide de respostas: mostrar depois que a turma responder. Pedir que um grupo que escolheu "trilhos" e um que escolheu "mesa" digam o que fariam; usar a terceira coluna para mostrar o risco de errar.</a:t>
             </a:r>
           </a:p>
         </p:txBody>
@@ -3492,7 +3492,7 @@
           <a:lstStyle/>
           <a:p>
             <a:r>
-              <a:t>Raciocínio esperado: o dado fortalece 'quer os trilhos' (ou as duas juntas) e enfraquece 'foge da mesa'. Mas são 4 sessões, sem controle de outras variáveis: é mais uma pista, não uma conclusão. Próximo passo: avaliação organizada, com supervisão.</a:t>
+              <a:t>Raciocínio esperado: o dado fortalece 'quer os trilhos' (ou as duas juntas) e enfraquece 'escapar da mesa'. Mas são 4 sessões, sem controle de outras variáveis: é mais uma pista, não uma conclusão. Próximo passo: avaliação organizada, com supervisão.</a:t>
             </a:r>
           </a:p>
         </p:txBody>
@@ -21903,8 +21903,8 @@
         </p:nvSpPr>
         <p:spPr>
           <a:xfrm>
-            <a:off x="1168400" y="1241227"/>
-            <a:ext cx="10307828" cy="423466"/>
+            <a:off x="1168400" y="932755"/>
+            <a:ext cx="10307828" cy="394295"/>
           </a:xfrm>
           <a:prstGeom prst="rect">
             <a:avLst/>
@@ -21923,28 +21923,67 @@
               </a:lnSpc>
             </a:pPr>
             <a:r>
-              <a:rPr sz="2900" b="1" i="0">
+              <a:rPr sz="2700" b="1" i="0">
                 <a:solidFill>
                   <a:srgbClr val="1B2F4B"/>
                 </a:solidFill>
                 <a:latin typeface="Montserrat"/>
               </a:rPr>
-              <a:t>Respostas 4: explicações possíveis</a:t>
+              <a:t>Respostas 4: por que o Theo faz isso?</a:t>
+            </a:r>
+          </a:p>
+        </p:txBody>
+      </p:sp>
+      <p:sp>
+        <p:nvSpPr>
+          <p:cNvPr id="4" name="TextBox 3"/>
+          <p:cNvSpPr txBox="1"/>
+          <p:nvPr/>
+        </p:nvSpPr>
+        <p:spPr>
+          <a:xfrm>
+            <a:off x="1168400" y="1492151"/>
+            <a:ext cx="10307828" cy="266700"/>
+          </a:xfrm>
+          <a:prstGeom prst="rect">
+            <a:avLst/>
+          </a:prstGeom>
+          <a:noFill/>
+        </p:spPr>
+        <p:txBody>
+          <a:bodyPr wrap="square" lIns="0" rIns="0" tIns="0" bIns="0" anchor="t">
+            <a:noAutofit/>
+          </a:bodyPr>
+          <a:lstStyle/>
+          <a:p>
+            <a:pPr algn="l">
+              <a:lnSpc>
+                <a:spcPct val="115000"/>
+              </a:lnSpc>
+            </a:pPr>
+            <a:r>
+              <a:rPr sz="1500" b="0" i="0">
+                <a:solidFill>
+                  <a:srgbClr val="66717F"/>
+                </a:solidFill>
+                <a:latin typeface="Montserrat"/>
+              </a:rPr>
+              <a:t>Quatro explicações possíveis, cada uma com o que a história mostra a favor e contra.</a:t>
             </a:r>
           </a:p>
         </p:txBody>
       </p:sp>
       <p:graphicFrame>
         <p:nvGraphicFramePr>
-          <p:cNvPr id="4" name="Table 3"/>
+          <p:cNvPr id="5" name="Table 4"/>
           <p:cNvGraphicFramePr>
             <a:graphicFrameLocks noGrp="1"/>
           </p:cNvGraphicFramePr>
           <p:nvPr/>
         </p:nvGraphicFramePr>
         <p:xfrm>
-          <a:off x="1168400" y="1855192"/>
-          <a:ext cx="10007600" cy="2819400"/>
+          <a:off x="1168400" y="1923951"/>
+          <a:ext cx="10007600" cy="3117453"/>
         </p:xfrm>
         <a:graphic>
           <a:graphicData uri="http://schemas.openxmlformats.org/drawingml/2006/table">
@@ -21953,11 +21992,11 @@
                 <a:tableStyleId>{2D5ABB26-0587-4C30-8999-92F81FD0307C}</a:tableStyleId>
               </a:tblPr>
               <a:tblGrid>
-                <a:gridCol w="2201664"/>
+                <a:gridCol w="2401788"/>
                 <a:gridCol w="4203105"/>
-                <a:gridCol w="3602831"/>
+                <a:gridCol w="3402707"/>
               </a:tblGrid>
-              <a:tr h="438150">
+              <a:tr h="400645">
                 <a:tc>
                   <a:txBody>
                     <a:bodyPr wrap="square"/>
@@ -21969,7 +22008,7 @@
                         </a:lnSpc>
                       </a:pPr>
                       <a:r>
-                        <a:rPr sz="1350" b="1" i="0">
+                        <a:rPr sz="1300" b="1" i="0">
                           <a:solidFill>
                             <a:srgbClr val="FFFFFF"/>
                           </a:solidFill>
@@ -21996,13 +22035,672 @@
                         </a:lnSpc>
                       </a:pPr>
                       <a:r>
+                        <a:rPr sz="1300" b="1" i="0">
+                          <a:solidFill>
+                            <a:srgbClr val="FFFFFF"/>
+                          </a:solidFill>
+                          <a:latin typeface="Montserrat"/>
+                        </a:rPr>
+                        <a:t>A favor (o que reforça a ideia)</a:t>
+                      </a:r>
+                    </a:p>
+                  </a:txBody>
+                  <a:tcPr marL="114300" marR="114300" marT="68580" marB="68580" anchor="ctr">
+                    <a:solidFill>
+                      <a:srgbClr val="1B2F4B"/>
+                    </a:solidFill>
+                  </a:tcPr>
+                </a:tc>
+                <a:tc>
+                  <a:txBody>
+                    <a:bodyPr wrap="square"/>
+                    <a:lstStyle/>
+                    <a:p>
+                      <a:pPr>
+                        <a:lnSpc>
+                          <a:spcPct val="100000"/>
+                        </a:lnSpc>
+                      </a:pPr>
+                      <a:r>
+                        <a:rPr sz="1300" b="1" i="0">
+                          <a:solidFill>
+                            <a:srgbClr val="FFFFFF"/>
+                          </a:solidFill>
+                          <a:latin typeface="Montserrat"/>
+                        </a:rPr>
+                        <a:t>Contra (o que enfraquece a ideia)</a:t>
+                      </a:r>
+                    </a:p>
+                  </a:txBody>
+                  <a:tcPr marL="114300" marR="114300" marT="68580" marB="68580" anchor="ctr">
+                    <a:solidFill>
+                      <a:srgbClr val="1B2F4B"/>
+                    </a:solidFill>
+                  </a:tcPr>
+                </a:tc>
+              </a:tr>
+              <a:tr h="846336">
+                <a:tc>
+                  <a:txBody>
+                    <a:bodyPr wrap="square"/>
+                    <a:lstStyle/>
+                    <a:p>
+                      <a:pPr>
+                        <a:lnSpc>
+                          <a:spcPct val="100000"/>
+                        </a:lnSpc>
+                      </a:pPr>
+                      <a:r>
+                        <a:rPr sz="1300" b="1" i="0">
+                          <a:solidFill>
+                            <a:srgbClr val="2E3A4A"/>
+                          </a:solidFill>
+                          <a:latin typeface="Montserrat"/>
+                        </a:rPr>
+                        <a:t>Ele quer continuar com os trilhos</a:t>
+                      </a:r>
+                    </a:p>
+                  </a:txBody>
+                  <a:tcPr marL="114300" marR="114300" marT="68580" marB="68580" anchor="ctr">
+                    <a:solidFill>
+                      <a:srgbClr val="FFFFFF"/>
+                    </a:solidFill>
+                  </a:tcPr>
+                </a:tc>
+                <a:tc>
+                  <a:txBody>
+                    <a:bodyPr wrap="square"/>
+                    <a:lstStyle/>
+                    <a:p>
+                      <a:pPr>
+                        <a:lnSpc>
+                          <a:spcPct val="100000"/>
+                        </a:lnSpc>
+                      </a:pPr>
+                      <a:r>
+                        <a:rPr sz="1300" b="0" i="0">
+                          <a:solidFill>
+                            <a:srgbClr val="2E3A4A"/>
+                          </a:solidFill>
+                          <a:latin typeface="Montserrat"/>
+                        </a:rPr>
+                        <a:t>O grito acontece quando os trilhos são guardados. Às vezes os trilhos voltam depois do grito. Em casa, acontece quando desligam a TV.</a:t>
+                      </a:r>
+                    </a:p>
+                  </a:txBody>
+                  <a:tcPr marL="114300" marR="114300" marT="68580" marB="68580" anchor="ctr">
+                    <a:solidFill>
+                      <a:srgbClr val="FFFFFF"/>
+                    </a:solidFill>
+                  </a:tcPr>
+                </a:tc>
+                <a:tc>
+                  <a:txBody>
+                    <a:bodyPr wrap="square"/>
+                    <a:lstStyle/>
+                    <a:p>
+                      <a:pPr>
+                        <a:lnSpc>
+                          <a:spcPct val="100000"/>
+                        </a:lnSpc>
+                      </a:pPr>
+                      <a:r>
+                        <a:rPr sz="1300" b="0" i="0">
+                          <a:solidFill>
+                            <a:srgbClr val="2E3A4A"/>
+                          </a:solidFill>
+                          <a:latin typeface="Montserrat"/>
+                        </a:rPr>
+                        <a:t>No dia do lanche, os trilhos também foram guardados, e ele </a:t>
+                      </a:r>
+                      <a:r>
+                        <a:rPr sz="1300" b="1" i="0">
+                          <a:solidFill>
+                            <a:srgbClr val="2E3A4A"/>
+                          </a:solidFill>
+                          <a:latin typeface="Montserrat"/>
+                        </a:rPr>
+                        <a:t>não</a:t>
+                      </a:r>
+                      <a:r>
+                        <a:rPr sz="1300" b="0" i="0">
+                          <a:solidFill>
+                            <a:srgbClr val="2E3A4A"/>
+                          </a:solidFill>
+                          <a:latin typeface="Montserrat"/>
+                        </a:rPr>
+                        <a:t> gritou.</a:t>
+                      </a:r>
+                    </a:p>
+                  </a:txBody>
+                  <a:tcPr marL="114300" marR="114300" marT="68580" marB="68580" anchor="ctr">
+                    <a:solidFill>
+                      <a:srgbClr val="FFFFFF"/>
+                    </a:solidFill>
+                  </a:tcPr>
+                </a:tc>
+              </a:tr>
+              <a:tr h="846336">
+                <a:tc>
+                  <a:txBody>
+                    <a:bodyPr wrap="square"/>
+                    <a:lstStyle/>
+                    <a:p>
+                      <a:pPr>
+                        <a:lnSpc>
+                          <a:spcPct val="100000"/>
+                        </a:lnSpc>
+                      </a:pPr>
+                      <a:r>
+                        <a:rPr sz="1300" b="1" i="0">
+                          <a:solidFill>
+                            <a:srgbClr val="2E3A4A"/>
+                          </a:solidFill>
+                          <a:latin typeface="Montserrat"/>
+                        </a:rPr>
+                        <a:t>Ele quer escapar da atividade de mesa</a:t>
+                      </a:r>
+                    </a:p>
+                  </a:txBody>
+                  <a:tcPr marL="114300" marR="114300" marT="68580" marB="68580" anchor="ctr">
+                    <a:solidFill>
+                      <a:srgbClr val="F1F4F6"/>
+                    </a:solidFill>
+                  </a:tcPr>
+                </a:tc>
+                <a:tc>
+                  <a:txBody>
+                    <a:bodyPr wrap="square"/>
+                    <a:lstStyle/>
+                    <a:p>
+                      <a:pPr>
+                        <a:lnSpc>
+                          <a:spcPct val="100000"/>
+                        </a:lnSpc>
+                      </a:pPr>
+                      <a:r>
+                        <a:rPr sz="1300" b="0" i="0">
+                          <a:solidFill>
+                            <a:srgbClr val="2E3A4A"/>
+                          </a:solidFill>
+                          <a:latin typeface="Montserrat"/>
+                        </a:rPr>
+                        <a:t>Quando o próximo é o lanche (algo de que ele gosta), não há grito. Às vezes a mesa é adiada depois do grito.</a:t>
+                      </a:r>
+                    </a:p>
+                  </a:txBody>
+                  <a:tcPr marL="114300" marR="114300" marT="68580" marB="68580" anchor="ctr">
+                    <a:solidFill>
+                      <a:srgbClr val="F1F4F6"/>
+                    </a:solidFill>
+                  </a:tcPr>
+                </a:tc>
+                <a:tc>
+                  <a:txBody>
+                    <a:bodyPr wrap="square"/>
+                    <a:lstStyle/>
+                    <a:p>
+                      <a:pPr>
+                        <a:lnSpc>
+                          <a:spcPct val="100000"/>
+                        </a:lnSpc>
+                      </a:pPr>
+                      <a:r>
+                        <a:rPr sz="1300" b="0" i="0">
+                          <a:solidFill>
+                            <a:srgbClr val="2E3A4A"/>
+                          </a:solidFill>
+                          <a:latin typeface="Montserrat"/>
+                        </a:rPr>
+                        <a:t>Em casa, o que vem depois é o banho, não uma tarefa de mesa.</a:t>
+                      </a:r>
+                    </a:p>
+                  </a:txBody>
+                  <a:tcPr marL="114300" marR="114300" marT="68580" marB="68580" anchor="ctr">
+                    <a:solidFill>
+                      <a:srgbClr val="F1F4F6"/>
+                    </a:solidFill>
+                  </a:tcPr>
+                </a:tc>
+              </a:tr>
+              <a:tr h="623491">
+                <a:tc>
+                  <a:txBody>
+                    <a:bodyPr wrap="square"/>
+                    <a:lstStyle/>
+                    <a:p>
+                      <a:pPr>
+                        <a:lnSpc>
+                          <a:spcPct val="100000"/>
+                        </a:lnSpc>
+                      </a:pPr>
+                      <a:r>
+                        <a:rPr sz="1300" b="1" i="0">
+                          <a:solidFill>
+                            <a:srgbClr val="2E3A4A"/>
+                          </a:solidFill>
+                          <a:latin typeface="Montserrat"/>
+                        </a:rPr>
+                        <a:t>As duas coisas juntas</a:t>
+                      </a:r>
+                    </a:p>
+                  </a:txBody>
+                  <a:tcPr marL="114300" marR="114300" marT="68580" marB="68580" anchor="ctr">
+                    <a:solidFill>
+                      <a:srgbClr val="FFFFFF"/>
+                    </a:solidFill>
+                  </a:tcPr>
+                </a:tc>
+                <a:tc>
+                  <a:txBody>
+                    <a:bodyPr wrap="square"/>
+                    <a:lstStyle/>
+                    <a:p>
+                      <a:pPr>
+                        <a:lnSpc>
+                          <a:spcPct val="100000"/>
+                        </a:lnSpc>
+                      </a:pPr>
+                      <a:r>
+                        <a:rPr sz="1300" b="0" i="0">
+                          <a:solidFill>
+                            <a:srgbClr val="2E3A4A"/>
+                          </a:solidFill>
+                          <a:latin typeface="Montserrat"/>
+                        </a:rPr>
+                        <a:t>Perder os trilhos e ir para a mesa acontecem no mesmo momento.</a:t>
+                      </a:r>
+                    </a:p>
+                  </a:txBody>
+                  <a:tcPr marL="114300" marR="114300" marT="68580" marB="68580" anchor="ctr">
+                    <a:solidFill>
+                      <a:srgbClr val="FFFFFF"/>
+                    </a:solidFill>
+                  </a:tcPr>
+                </a:tc>
+                <a:tc>
+                  <a:txBody>
+                    <a:bodyPr wrap="square"/>
+                    <a:lstStyle/>
+                    <a:p>
+                      <a:pPr>
+                        <a:lnSpc>
+                          <a:spcPct val="100000"/>
+                        </a:lnSpc>
+                      </a:pPr>
+                      <a:r>
+                        <a:rPr sz="1300" b="0" i="0">
+                          <a:solidFill>
+                            <a:srgbClr val="2E3A4A"/>
+                          </a:solidFill>
+                          <a:latin typeface="Montserrat"/>
+                        </a:rPr>
+                        <a:t>Só uma avaliação consegue separar as duas.</a:t>
+                      </a:r>
+                    </a:p>
+                  </a:txBody>
+                  <a:tcPr marL="114300" marR="114300" marT="68580" marB="68580" anchor="ctr">
+                    <a:solidFill>
+                      <a:srgbClr val="FFFFFF"/>
+                    </a:solidFill>
+                  </a:tcPr>
+                </a:tc>
+              </a:tr>
+              <a:tr h="400645">
+                <a:tc>
+                  <a:txBody>
+                    <a:bodyPr wrap="square"/>
+                    <a:lstStyle/>
+                    <a:p>
+                      <a:pPr>
+                        <a:lnSpc>
+                          <a:spcPct val="100000"/>
+                        </a:lnSpc>
+                      </a:pPr>
+                      <a:r>
+                        <a:rPr sz="1300" b="1" i="0">
+                          <a:solidFill>
+                            <a:srgbClr val="2E3A4A"/>
+                          </a:solidFill>
+                          <a:latin typeface="Montserrat"/>
+                        </a:rPr>
+                        <a:t>Ele quer atenção</a:t>
+                      </a:r>
+                    </a:p>
+                  </a:txBody>
+                  <a:tcPr marL="114300" marR="114300" marT="68580" marB="68580" anchor="ctr">
+                    <a:solidFill>
+                      <a:srgbClr val="F1F4F6"/>
+                    </a:solidFill>
+                  </a:tcPr>
+                </a:tc>
+                <a:tc>
+                  <a:txBody>
+                    <a:bodyPr wrap="square"/>
+                    <a:lstStyle/>
+                    <a:p>
+                      <a:pPr>
+                        <a:lnSpc>
+                          <a:spcPct val="100000"/>
+                        </a:lnSpc>
+                      </a:pPr>
+                      <a:r>
+                        <a:rPr sz="1300" b="0" i="0">
+                          <a:solidFill>
+                            <a:srgbClr val="2E3A4A"/>
+                          </a:solidFill>
+                          <a:latin typeface="Montserrat"/>
+                        </a:rPr>
+                        <a:t>Talvez receba atenção enquanto grita.</a:t>
+                      </a:r>
+                    </a:p>
+                  </a:txBody>
+                  <a:tcPr marL="114300" marR="114300" marT="68580" marB="68580" anchor="ctr">
+                    <a:solidFill>
+                      <a:srgbClr val="F1F4F6"/>
+                    </a:solidFill>
+                  </a:tcPr>
+                </a:tc>
+                <a:tc>
+                  <a:txBody>
+                    <a:bodyPr wrap="square"/>
+                    <a:lstStyle/>
+                    <a:p>
+                      <a:pPr>
+                        <a:lnSpc>
+                          <a:spcPct val="100000"/>
+                        </a:lnSpc>
+                      </a:pPr>
+                      <a:r>
+                        <a:rPr sz="1300" b="0" i="0">
+                          <a:solidFill>
+                            <a:srgbClr val="2E3A4A"/>
+                          </a:solidFill>
+                          <a:latin typeface="Montserrat"/>
+                        </a:rPr>
+                        <a:t>Nada na história mostra isso.</a:t>
+                      </a:r>
+                    </a:p>
+                  </a:txBody>
+                  <a:tcPr marL="114300" marR="114300" marT="68580" marB="68580" anchor="ctr">
+                    <a:solidFill>
+                      <a:srgbClr val="F1F4F6"/>
+                    </a:solidFill>
+                  </a:tcPr>
+                </a:tc>
+              </a:tr>
+            </a:tbl>
+          </a:graphicData>
+        </a:graphic>
+      </p:graphicFrame>
+      <p:sp>
+        <p:nvSpPr>
+          <p:cNvPr id="6" name="TextBox 5"/>
+          <p:cNvSpPr txBox="1"/>
+          <p:nvPr/>
+        </p:nvSpPr>
+        <p:spPr>
+          <a:xfrm>
+            <a:off x="1168400" y="5206504"/>
+            <a:ext cx="10307828" cy="528241"/>
+          </a:xfrm>
+          <a:prstGeom prst="rect">
+            <a:avLst/>
+          </a:prstGeom>
+          <a:noFill/>
+        </p:spPr>
+        <p:txBody>
+          <a:bodyPr wrap="square" lIns="0" rIns="0" tIns="0" bIns="0" anchor="t">
+            <a:noAutofit/>
+          </a:bodyPr>
+          <a:lstStyle/>
+          <a:p>
+            <a:pPr algn="l">
+              <a:lnSpc>
+                <a:spcPct val="107000"/>
+              </a:lnSpc>
+            </a:pPr>
+            <a:r>
+              <a:rPr sz="1600" b="1" i="0">
+                <a:solidFill>
+                  <a:srgbClr val="0F7C86"/>
+                </a:solidFill>
+                <a:latin typeface="Montserrat"/>
+              </a:rPr>
+              <a:t>A pista mais forte é o lanche: os trilhos foram guardados e ele não gritou. Isso torna mais provável “escapar da mesa” (ou as duas juntas). Ainda são hipóteses.</a:t>
+            </a:r>
+          </a:p>
+        </p:txBody>
+      </p:sp>
+      <p:sp>
+        <p:nvSpPr>
+          <p:cNvPr id="7" name="TextBox 6"/>
+          <p:cNvSpPr txBox="1"/>
+          <p:nvPr/>
+        </p:nvSpPr>
+        <p:spPr>
+          <a:xfrm>
+            <a:off x="10820400" y="6343650"/>
+            <a:ext cx="784860" cy="184150"/>
+          </a:xfrm>
+          <a:prstGeom prst="rect">
+            <a:avLst/>
+          </a:prstGeom>
+          <a:noFill/>
+        </p:spPr>
+        <p:txBody>
+          <a:bodyPr wrap="square" lIns="0" rIns="0" tIns="0" bIns="0" anchor="t">
+            <a:noAutofit/>
+          </a:bodyPr>
+          <a:lstStyle/>
+          <a:p>
+            <a:pPr algn="r">
+              <a:lnSpc>
+                <a:spcPct val="98000"/>
+              </a:lnSpc>
+            </a:pPr>
+            <a:r>
+              <a:rPr sz="1200" b="0" i="0">
+                <a:solidFill>
+                  <a:srgbClr val="66717F"/>
+                </a:solidFill>
+                <a:latin typeface="Montserrat"/>
+              </a:rPr>
+              <a:t>44</a:t>
+            </a:r>
+          </a:p>
+        </p:txBody>
+      </p:sp>
+    </p:spTree>
+  </p:cSld>
+  <p:clrMapOvr>
+    <a:masterClrMapping/>
+  </p:clrMapOvr>
+</p:sld>
+</file>
+
+<file path=ppt/slides/slide45.xml><?xml version="1.0" encoding="utf-8"?>
+<p:sld xmlns:a="http://schemas.openxmlformats.org/drawingml/2006/main" xmlns:p="http://schemas.openxmlformats.org/presentationml/2006/main" xmlns:r="http://schemas.openxmlformats.org/officeDocument/2006/relationships">
+  <p:cSld>
+    <p:bg>
+      <p:bgPr>
+        <a:solidFill>
+          <a:srgbClr val="FFFFFF"/>
+        </a:solidFill>
+        <a:effectLst/>
+      </p:bgPr>
+    </p:bg>
+    <p:spTree>
+      <p:nvGrpSpPr>
+        <p:cNvPr id="1" name=""/>
+        <p:cNvGrpSpPr/>
+        <p:nvPr/>
+      </p:nvGrpSpPr>
+      <p:grpSpPr/>
+      <p:sp>
+        <p:nvSpPr>
+          <p:cNvPr id="2" name="Rectangle 1"/>
+          <p:cNvSpPr/>
+          <p:nvPr/>
+        </p:nvSpPr>
+        <p:spPr>
+          <a:xfrm>
+            <a:off x="0" y="0"/>
+            <a:ext cx="177800" cy="6858000"/>
+          </a:xfrm>
+          <a:prstGeom prst="rect">
+            <a:avLst/>
+          </a:prstGeom>
+          <a:solidFill>
+            <a:srgbClr val="0F7C86"/>
+          </a:solidFill>
+          <a:ln>
+            <a:noFill/>
+          </a:ln>
+          <a:effectLst/>
+        </p:spPr>
+        <p:style>
+          <a:lnRef idx="1">
+            <a:schemeClr val="accent1"/>
+          </a:lnRef>
+          <a:fillRef idx="3">
+            <a:schemeClr val="accent1"/>
+          </a:fillRef>
+          <a:effectRef idx="2">
+            <a:schemeClr val="accent1"/>
+          </a:effectRef>
+          <a:fontRef idx="minor">
+            <a:schemeClr val="lt1"/>
+          </a:fontRef>
+        </p:style>
+        <p:txBody>
+          <a:bodyPr rtlCol="0" anchor="ctr"/>
+          <a:lstStyle/>
+          <a:p>
+            <a:pPr algn="ctr"/>
+          </a:p>
+        </p:txBody>
+      </p:sp>
+      <p:sp>
+        <p:nvSpPr>
+          <p:cNvPr id="3" name="TextBox 2"/>
+          <p:cNvSpPr txBox="1"/>
+          <p:nvPr/>
+        </p:nvSpPr>
+        <p:spPr>
+          <a:xfrm>
+            <a:off x="1168400" y="984250"/>
+            <a:ext cx="10307828" cy="788591"/>
+          </a:xfrm>
+          <a:prstGeom prst="rect">
+            <a:avLst/>
+          </a:prstGeom>
+          <a:noFill/>
+        </p:spPr>
+        <p:txBody>
+          <a:bodyPr wrap="square" lIns="0" rIns="0" tIns="0" bIns="0" anchor="t">
+            <a:noAutofit/>
+          </a:bodyPr>
+          <a:lstStyle/>
+          <a:p>
+            <a:pPr algn="l">
+              <a:lnSpc>
+                <a:spcPct val="94000"/>
+              </a:lnSpc>
+            </a:pPr>
+            <a:r>
+              <a:rPr sz="2700" b="1" i="0">
+                <a:solidFill>
+                  <a:srgbClr val="1B2F4B"/>
+                </a:solidFill>
+                <a:latin typeface="Montserrat"/>
+              </a:rPr>
+              <a:t>Respostas 5: o que fazer, e se a explicação estiver errada?</a:t>
+            </a:r>
+          </a:p>
+        </p:txBody>
+      </p:sp>
+      <p:sp>
+        <p:nvSpPr>
+          <p:cNvPr id="4" name="TextBox 3"/>
+          <p:cNvSpPr txBox="1"/>
+          <p:nvPr/>
+        </p:nvSpPr>
+        <p:spPr>
+          <a:xfrm>
+            <a:off x="1168400" y="1937941"/>
+            <a:ext cx="10307828" cy="266700"/>
+          </a:xfrm>
+          <a:prstGeom prst="rect">
+            <a:avLst/>
+          </a:prstGeom>
+          <a:noFill/>
+        </p:spPr>
+        <p:txBody>
+          <a:bodyPr wrap="square" lIns="0" rIns="0" tIns="0" bIns="0" anchor="t">
+            <a:noAutofit/>
+          </a:bodyPr>
+          <a:lstStyle/>
+          <a:p>
+            <a:pPr algn="l">
+              <a:lnSpc>
+                <a:spcPct val="115000"/>
+              </a:lnSpc>
+            </a:pPr>
+            <a:r>
+              <a:rPr sz="1500" b="0" i="0">
+                <a:solidFill>
+                  <a:srgbClr val="66717F"/>
+                </a:solidFill>
+                <a:latin typeface="Montserrat"/>
+              </a:rPr>
+              <a:t>Cada estratégia combina com uma explicação. Se a explicação estiver errada, a estratégia falha.</a:t>
+            </a:r>
+          </a:p>
+        </p:txBody>
+      </p:sp>
+      <p:graphicFrame>
+        <p:nvGraphicFramePr>
+          <p:cNvPr id="5" name="Table 4"/>
+          <p:cNvGraphicFramePr>
+            <a:graphicFrameLocks noGrp="1"/>
+          </p:cNvGraphicFramePr>
+          <p:nvPr/>
+        </p:nvGraphicFramePr>
+        <p:xfrm>
+          <a:off x="1168400" y="2369741"/>
+          <a:ext cx="10007599" cy="1921668"/>
+        </p:xfrm>
+        <a:graphic>
+          <a:graphicData uri="http://schemas.openxmlformats.org/drawingml/2006/table">
+            <a:tbl>
+              <a:tblPr firstRow="0" bandRow="0">
+                <a:tableStyleId>{2D5ABB26-0587-4C30-8999-92F81FD0307C}</a:tableStyleId>
+              </a:tblPr>
+              <a:tblGrid>
+                <a:gridCol w="2401788"/>
+                <a:gridCol w="4002980"/>
+                <a:gridCol w="3602831"/>
+              </a:tblGrid>
+              <a:tr h="409178">
+                <a:tc>
+                  <a:txBody>
+                    <a:bodyPr wrap="square"/>
+                    <a:lstStyle/>
+                    <a:p>
+                      <a:pPr>
+                        <a:lnSpc>
+                          <a:spcPct val="100000"/>
+                        </a:lnSpc>
+                      </a:pPr>
+                      <a:r>
                         <a:rPr sz="1350" b="1" i="0">
                           <a:solidFill>
                             <a:srgbClr val="FFFFFF"/>
                           </a:solidFill>
                           <a:latin typeface="Montserrat"/>
                         </a:rPr>
-                        <a:t>Dado que ajuda</a:t>
+                        <a:t>Se achamos que ele…</a:t>
                       </a:r>
                     </a:p>
                   </a:txBody>
@@ -22029,7 +22727,34 @@
                           </a:solidFill>
                           <a:latin typeface="Montserrat"/>
                         </a:rPr>
-                        <a:t>Dado que atrapalha</a:t>
+                        <a:t>Podemos…</a:t>
+                      </a:r>
+                    </a:p>
+                  </a:txBody>
+                  <a:tcPr marL="114300" marR="114300" marT="68580" marB="68580" anchor="ctr">
+                    <a:solidFill>
+                      <a:srgbClr val="1B2F4B"/>
+                    </a:solidFill>
+                  </a:tcPr>
+                </a:tc>
+                <a:tc>
+                  <a:txBody>
+                    <a:bodyPr wrap="square"/>
+                    <a:lstStyle/>
+                    <a:p>
+                      <a:pPr>
+                        <a:lnSpc>
+                          <a:spcPct val="100000"/>
+                        </a:lnSpc>
+                      </a:pPr>
+                      <a:r>
+                        <a:rPr sz="1350" b="1" i="0">
+                          <a:solidFill>
+                            <a:srgbClr val="FFFFFF"/>
+                          </a:solidFill>
+                          <a:latin typeface="Montserrat"/>
+                        </a:rPr>
+                        <a:t>Mas, se a explicação estiver errada…</a:t>
                       </a:r>
                     </a:p>
                   </a:txBody>
@@ -22040,7 +22765,7 @@
                   </a:tcPr>
                 </a:tc>
               </a:tr>
-              <a:tr h="647700">
+              <a:tr h="871934">
                 <a:tc>
                   <a:txBody>
                     <a:bodyPr wrap="square"/>
@@ -22058,7 +22783,7 @@
                           </a:solidFill>
                           <a:latin typeface="Montserrat"/>
                         </a:rPr>
-                        <a:t>Quer os trilhos</a:t>
+                        <a:t>quer os trilhos</a:t>
                       </a:r>
                     </a:p>
                   </a:txBody>
@@ -22085,7 +22810,7 @@
                           </a:solidFill>
                           <a:latin typeface="Montserrat"/>
                         </a:rPr>
-                        <a:t>Acontece quando os trilhos são guardados; às vezes eles voltam; em casa, ao desligar a TV</a:t>
+                        <a:t>Combinar “primeiro mesa, depois trem” e devolver os trilhos ao terminar. Ensinar a pedir “mais trem” e a esperar.</a:t>
                       </a:r>
                     </a:p>
                   </a:txBody>
@@ -22112,7 +22837,7 @@
                           </a:solidFill>
                           <a:latin typeface="Montserrat"/>
                         </a:rPr>
-                        <a:t>No lanche os trilhos também foram guardados, e não houve episódio</a:t>
+                        <a:t>Se na verdade ele quer escapar da mesa, quase nada muda: a mesa continua difícil e o grito continua.</a:t>
                       </a:r>
                     </a:p>
                   </a:txBody>
@@ -22123,7 +22848,7 @@
                   </a:tcPr>
                 </a:tc>
               </a:tr>
-              <a:tr h="647700">
+              <a:tr h="640556">
                 <a:tc>
                   <a:txBody>
                     <a:bodyPr wrap="square"/>
@@ -22141,7 +22866,7 @@
                           </a:solidFill>
                           <a:latin typeface="Montserrat"/>
                         </a:rPr>
-                        <a:t>Foge da mesa</a:t>
+                        <a:t>quer escapar da mesa</a:t>
                       </a:r>
                     </a:p>
                   </a:txBody>
@@ -22168,7 +22893,7 @@
                           </a:solidFill>
                           <a:latin typeface="Montserrat"/>
                         </a:rPr>
-                        <a:t>Não acontece quando o próximo é o lanche; às vezes a mesa é adiada</a:t>
+                        <a:t>Deixar a tarefa mais curta e mais fácil, com tema de trens. Ensinar a pedir “pausa”.</a:t>
                       </a:r>
                     </a:p>
                   </a:txBody>
@@ -22195,173 +22920,7 @@
                           </a:solidFill>
                           <a:latin typeface="Montserrat"/>
                         </a:rPr>
-                        <a:t>Em casa, o antecedente (o que vem antes) é o banho</a:t>
-                      </a:r>
-                    </a:p>
-                  </a:txBody>
-                  <a:tcPr marL="114300" marR="114300" marT="68580" marB="68580" anchor="ctr">
-                    <a:solidFill>
-                      <a:srgbClr val="F1F4F6"/>
-                    </a:solidFill>
-                  </a:tcPr>
-                </a:tc>
-              </a:tr>
-              <a:tr h="647700">
-                <a:tc>
-                  <a:txBody>
-                    <a:bodyPr wrap="square"/>
-                    <a:lstStyle/>
-                    <a:p>
-                      <a:pPr>
-                        <a:lnSpc>
-                          <a:spcPct val="100000"/>
-                        </a:lnSpc>
-                      </a:pPr>
-                      <a:r>
-                        <a:rPr sz="1350" b="1" i="0">
-                          <a:solidFill>
-                            <a:srgbClr val="2E3A4A"/>
-                          </a:solidFill>
-                          <a:latin typeface="Montserrat"/>
-                        </a:rPr>
-                        <a:t>As duas juntas</a:t>
-                      </a:r>
-                    </a:p>
-                  </a:txBody>
-                  <a:tcPr marL="114300" marR="114300" marT="68580" marB="68580" anchor="ctr">
-                    <a:solidFill>
-                      <a:srgbClr val="FFFFFF"/>
-                    </a:solidFill>
-                  </a:tcPr>
-                </a:tc>
-                <a:tc>
-                  <a:txBody>
-                    <a:bodyPr wrap="square"/>
-                    <a:lstStyle/>
-                    <a:p>
-                      <a:pPr>
-                        <a:lnSpc>
-                          <a:spcPct val="100000"/>
-                        </a:lnSpc>
-                      </a:pPr>
-                      <a:r>
-                        <a:rPr sz="1350" b="0" i="0">
-                          <a:solidFill>
-                            <a:srgbClr val="2E3A4A"/>
-                          </a:solidFill>
-                          <a:latin typeface="Montserrat"/>
-                        </a:rPr>
-                        <a:t>Os dois antecedentes acontecem ao mesmo tempo</a:t>
-                      </a:r>
-                    </a:p>
-                  </a:txBody>
-                  <a:tcPr marL="114300" marR="114300" marT="68580" marB="68580" anchor="ctr">
-                    <a:solidFill>
-                      <a:srgbClr val="FFFFFF"/>
-                    </a:solidFill>
-                  </a:tcPr>
-                </a:tc>
-                <a:tc>
-                  <a:txBody>
-                    <a:bodyPr wrap="square"/>
-                    <a:lstStyle/>
-                    <a:p>
-                      <a:pPr>
-                        <a:lnSpc>
-                          <a:spcPct val="100000"/>
-                        </a:lnSpc>
-                      </a:pPr>
-                      <a:r>
-                        <a:rPr sz="1350" b="0" i="0">
-                          <a:solidFill>
-                            <a:srgbClr val="2E3A4A"/>
-                          </a:solidFill>
-                          <a:latin typeface="Montserrat"/>
-                        </a:rPr>
-                        <a:t>Precisa de avaliação</a:t>
-                      </a:r>
-                    </a:p>
-                  </a:txBody>
-                  <a:tcPr marL="114300" marR="114300" marT="68580" marB="68580" anchor="ctr">
-                    <a:solidFill>
-                      <a:srgbClr val="FFFFFF"/>
-                    </a:solidFill>
-                  </a:tcPr>
-                </a:tc>
-              </a:tr>
-              <a:tr h="438150">
-                <a:tc>
-                  <a:txBody>
-                    <a:bodyPr wrap="square"/>
-                    <a:lstStyle/>
-                    <a:p>
-                      <a:pPr>
-                        <a:lnSpc>
-                          <a:spcPct val="100000"/>
-                        </a:lnSpc>
-                      </a:pPr>
-                      <a:r>
-                        <a:rPr sz="1350" b="1" i="0">
-                          <a:solidFill>
-                            <a:srgbClr val="2E3A4A"/>
-                          </a:solidFill>
-                          <a:latin typeface="Montserrat"/>
-                        </a:rPr>
-                        <a:t>Quer atenção</a:t>
-                      </a:r>
-                    </a:p>
-                  </a:txBody>
-                  <a:tcPr marL="114300" marR="114300" marT="68580" marB="68580" anchor="ctr">
-                    <a:solidFill>
-                      <a:srgbClr val="F1F4F6"/>
-                    </a:solidFill>
-                  </a:tcPr>
-                </a:tc>
-                <a:tc>
-                  <a:txBody>
-                    <a:bodyPr wrap="square"/>
-                    <a:lstStyle/>
-                    <a:p>
-                      <a:pPr>
-                        <a:lnSpc>
-                          <a:spcPct val="100000"/>
-                        </a:lnSpc>
-                      </a:pPr>
-                      <a:r>
-                        <a:rPr sz="1350" b="0" i="0">
-                          <a:solidFill>
-                            <a:srgbClr val="2E3A4A"/>
-                          </a:solidFill>
-                          <a:latin typeface="Montserrat"/>
-                        </a:rPr>
-                        <a:t>Possível atenção durante o episódio</a:t>
-                      </a:r>
-                    </a:p>
-                  </a:txBody>
-                  <a:tcPr marL="114300" marR="114300" marT="68580" marB="68580" anchor="ctr">
-                    <a:solidFill>
-                      <a:srgbClr val="F1F4F6"/>
-                    </a:solidFill>
-                  </a:tcPr>
-                </a:tc>
-                <a:tc>
-                  <a:txBody>
-                    <a:bodyPr wrap="square"/>
-                    <a:lstStyle/>
-                    <a:p>
-                      <a:pPr>
-                        <a:lnSpc>
-                          <a:spcPct val="100000"/>
-                        </a:lnSpc>
-                      </a:pPr>
-                      <a:r>
-                        <a:rPr sz="1350" b="0" i="0">
-                          <a:solidFill>
-                            <a:srgbClr val="2E3A4A"/>
-                          </a:solidFill>
-                          <a:latin typeface="Montserrat"/>
-                        </a:rPr>
-                        <a:t>Nenhum dado mostra isso</a:t>
+                        <a:t>Se na verdade ele quer os trilhos, o grito na hora de guardá-los continua.</a:t>
                       </a:r>
                     </a:p>
                   </a:txBody>
@@ -22378,14 +22937,14 @@
       </p:graphicFrame>
       <p:sp>
         <p:nvSpPr>
-          <p:cNvPr id="5" name="TextBox 4"/>
-          <p:cNvSpPr txBox="1"/>
-          <p:nvPr/>
-        </p:nvSpPr>
-        <p:spPr>
-          <a:xfrm>
-            <a:off x="1168400" y="4865092"/>
-            <a:ext cx="10307828" cy="561181"/>
+          <p:cNvPr id="6" name="TextBox 5"/>
+          <p:cNvSpPr txBox="1"/>
+          <p:nvPr/>
+        </p:nvSpPr>
+        <p:spPr>
+          <a:xfrm>
+            <a:off x="1168400" y="4456509"/>
+            <a:ext cx="10307828" cy="533400"/>
           </a:xfrm>
           <a:prstGeom prst="rect">
             <a:avLst/>
@@ -22400,488 +22959,72 @@
           <a:p>
             <a:pPr algn="l">
               <a:lnSpc>
+                <a:spcPct val="115000"/>
+              </a:lnSpc>
+            </a:pPr>
+            <a:r>
+              <a:rPr sz="1500" b="1" i="0">
+                <a:solidFill>
+                  <a:srgbClr val="2E3A4A"/>
+                </a:solidFill>
+                <a:latin typeface="Montserrat"/>
+              </a:rPr>
+              <a:t>Cuidado:</a:t>
+            </a:r>
+            <a:r>
+              <a:rPr sz="1500" b="0" i="0">
+                <a:solidFill>
+                  <a:srgbClr val="2E3A4A"/>
+                </a:solidFill>
+                <a:latin typeface="Montserrat"/>
+              </a:rPr>
+              <a:t> adiar a mesa sempre que ele grita, “para acalmar”, ensina que gritar faz a mesa sumir. O grito tende a aumentar.</a:t>
+            </a:r>
+          </a:p>
+        </p:txBody>
+      </p:sp>
+      <p:sp>
+        <p:nvSpPr>
+          <p:cNvPr id="7" name="TextBox 6"/>
+          <p:cNvSpPr txBox="1"/>
+          <p:nvPr/>
+        </p:nvSpPr>
+        <p:spPr>
+          <a:xfrm>
+            <a:off x="1168400" y="5155009"/>
+            <a:ext cx="10307828" cy="528241"/>
+          </a:xfrm>
+          <a:prstGeom prst="rect">
+            <a:avLst/>
+          </a:prstGeom>
+          <a:noFill/>
+        </p:spPr>
+        <p:txBody>
+          <a:bodyPr wrap="square" lIns="0" rIns="0" tIns="0" bIns="0" anchor="t">
+            <a:noAutofit/>
+          </a:bodyPr>
+          <a:lstStyle/>
+          <a:p>
+            <a:pPr algn="l">
+              <a:lnSpc>
                 <a:spcPct val="107000"/>
               </a:lnSpc>
             </a:pPr>
             <a:r>
-              <a:rPr sz="1700" b="1" i="0">
+              <a:rPr sz="1600" b="1" i="0">
                 <a:solidFill>
                   <a:srgbClr val="0F7C86"/>
                 </a:solidFill>
                 <a:latin typeface="Montserrat"/>
               </a:rPr>
-              <a:t>O lanche é a pista: enfraquece “quer os trilhos” e fortalece “foge da mesa” (ou as duas juntas).</a:t>
-            </a:r>
-          </a:p>
-        </p:txBody>
-      </p:sp>
-      <p:sp>
-        <p:nvSpPr>
-          <p:cNvPr id="6" name="TextBox 5"/>
-          <p:cNvSpPr txBox="1"/>
-          <p:nvPr/>
-        </p:nvSpPr>
-        <p:spPr>
-          <a:xfrm>
-            <a:off x="10820400" y="6343650"/>
-            <a:ext cx="784860" cy="184150"/>
-          </a:xfrm>
-          <a:prstGeom prst="rect">
-            <a:avLst/>
-          </a:prstGeom>
-          <a:noFill/>
-        </p:spPr>
-        <p:txBody>
-          <a:bodyPr wrap="square" lIns="0" rIns="0" tIns="0" bIns="0" anchor="t">
-            <a:noAutofit/>
-          </a:bodyPr>
-          <a:lstStyle/>
-          <a:p>
-            <a:pPr algn="r">
-              <a:lnSpc>
-                <a:spcPct val="98000"/>
-              </a:lnSpc>
-            </a:pPr>
-            <a:r>
-              <a:rPr sz="1200" b="0" i="0">
-                <a:solidFill>
-                  <a:srgbClr val="66717F"/>
-                </a:solidFill>
-                <a:latin typeface="Montserrat"/>
-              </a:rPr>
-              <a:t>44</a:t>
-            </a:r>
-          </a:p>
-        </p:txBody>
-      </p:sp>
-    </p:spTree>
-  </p:cSld>
-  <p:clrMapOvr>
-    <a:masterClrMapping/>
-  </p:clrMapOvr>
-</p:sld>
-</file>
-
-<file path=ppt/slides/slide45.xml><?xml version="1.0" encoding="utf-8"?>
-<p:sld xmlns:a="http://schemas.openxmlformats.org/drawingml/2006/main" xmlns:p="http://schemas.openxmlformats.org/presentationml/2006/main" xmlns:r="http://schemas.openxmlformats.org/officeDocument/2006/relationships">
-  <p:cSld>
-    <p:bg>
-      <p:bgPr>
-        <a:solidFill>
-          <a:srgbClr val="FFFFFF"/>
-        </a:solidFill>
-        <a:effectLst/>
-      </p:bgPr>
-    </p:bg>
-    <p:spTree>
-      <p:nvGrpSpPr>
-        <p:cNvPr id="1" name=""/>
-        <p:cNvGrpSpPr/>
-        <p:nvPr/>
-      </p:nvGrpSpPr>
-      <p:grpSpPr/>
-      <p:sp>
-        <p:nvSpPr>
-          <p:cNvPr id="2" name="Rectangle 1"/>
-          <p:cNvSpPr/>
-          <p:nvPr/>
-        </p:nvSpPr>
-        <p:spPr>
-          <a:xfrm>
-            <a:off x="0" y="0"/>
-            <a:ext cx="177800" cy="6858000"/>
-          </a:xfrm>
-          <a:prstGeom prst="rect">
-            <a:avLst/>
-          </a:prstGeom>
-          <a:solidFill>
-            <a:srgbClr val="0F7C86"/>
-          </a:solidFill>
-          <a:ln>
-            <a:noFill/>
-          </a:ln>
-          <a:effectLst/>
-        </p:spPr>
-        <p:style>
-          <a:lnRef idx="1">
-            <a:schemeClr val="accent1"/>
-          </a:lnRef>
-          <a:fillRef idx="3">
-            <a:schemeClr val="accent1"/>
-          </a:fillRef>
-          <a:effectRef idx="2">
-            <a:schemeClr val="accent1"/>
-          </a:effectRef>
-          <a:fontRef idx="minor">
-            <a:schemeClr val="lt1"/>
-          </a:fontRef>
-        </p:style>
-        <p:txBody>
-          <a:bodyPr rtlCol="0" anchor="ctr"/>
-          <a:lstStyle/>
-          <a:p>
-            <a:pPr algn="ctr"/>
-          </a:p>
-        </p:txBody>
-      </p:sp>
-      <p:sp>
-        <p:nvSpPr>
-          <p:cNvPr id="3" name="TextBox 2"/>
-          <p:cNvSpPr txBox="1"/>
-          <p:nvPr/>
-        </p:nvSpPr>
-        <p:spPr>
-          <a:xfrm>
-            <a:off x="1168400" y="1343720"/>
-            <a:ext cx="10307828" cy="817761"/>
-          </a:xfrm>
-          <a:prstGeom prst="rect">
-            <a:avLst/>
-          </a:prstGeom>
-          <a:noFill/>
-        </p:spPr>
-        <p:txBody>
-          <a:bodyPr wrap="square" lIns="0" rIns="0" tIns="0" bIns="0" anchor="t">
-            <a:noAutofit/>
-          </a:bodyPr>
-          <a:lstStyle/>
-          <a:p>
-            <a:pPr algn="l">
-              <a:lnSpc>
-                <a:spcPct val="94000"/>
-              </a:lnSpc>
-            </a:pPr>
-            <a:r>
-              <a:rPr sz="2800" b="1" i="0">
-                <a:solidFill>
-                  <a:srgbClr val="1B2F4B"/>
-                </a:solidFill>
-                <a:latin typeface="Montserrat"/>
-              </a:rPr>
-              <a:t>Respostas 5: o que fazer, e se a explicação estiver errada?</a:t>
-            </a:r>
-          </a:p>
-        </p:txBody>
-      </p:sp>
-      <p:graphicFrame>
-        <p:nvGraphicFramePr>
-          <p:cNvPr id="4" name="Table 3"/>
-          <p:cNvGraphicFramePr>
-            <a:graphicFrameLocks noGrp="1"/>
-          </p:cNvGraphicFramePr>
-          <p:nvPr/>
-        </p:nvGraphicFramePr>
-        <p:xfrm>
-          <a:off x="1168400" y="2415480"/>
-          <a:ext cx="10007600" cy="2324100"/>
-        </p:xfrm>
-        <a:graphic>
-          <a:graphicData uri="http://schemas.openxmlformats.org/drawingml/2006/table">
-            <a:tbl>
-              <a:tblPr firstRow="0" bandRow="0">
-                <a:tableStyleId>{2D5ABB26-0587-4C30-8999-92F81FD0307C}</a:tableStyleId>
-              </a:tblPr>
-              <a:tblGrid>
-                <a:gridCol w="5203924"/>
-                <a:gridCol w="4803676"/>
-              </a:tblGrid>
-              <a:tr h="463550">
-                <a:tc>
-                  <a:txBody>
-                    <a:bodyPr wrap="square"/>
-                    <a:lstStyle/>
-                    <a:p>
-                      <a:pPr>
-                        <a:lnSpc>
-                          <a:spcPct val="100000"/>
-                        </a:lnSpc>
-                      </a:pPr>
-                      <a:r>
-                        <a:rPr sz="1500" b="1" i="0">
-                          <a:solidFill>
-                            <a:srgbClr val="FFFFFF"/>
-                          </a:solidFill>
-                          <a:latin typeface="Montserrat"/>
-                        </a:rPr>
-                        <a:t>Se a explicação for…, podemos…</a:t>
-                      </a:r>
-                    </a:p>
-                  </a:txBody>
-                  <a:tcPr marL="114300" marR="114300" marT="68580" marB="68580" anchor="ctr">
-                    <a:solidFill>
-                      <a:srgbClr val="1B2F4B"/>
-                    </a:solidFill>
-                  </a:tcPr>
-                </a:tc>
-                <a:tc>
-                  <a:txBody>
-                    <a:bodyPr wrap="square"/>
-                    <a:lstStyle/>
-                    <a:p>
-                      <a:pPr>
-                        <a:lnSpc>
-                          <a:spcPct val="100000"/>
-                        </a:lnSpc>
-                      </a:pPr>
-                      <a:r>
-                        <a:rPr sz="1500" b="1" i="0">
-                          <a:solidFill>
-                            <a:srgbClr val="FFFFFF"/>
-                          </a:solidFill>
-                          <a:latin typeface="Montserrat"/>
-                        </a:rPr>
-                        <a:t>Se a explicação estiver errada…</a:t>
-                      </a:r>
-                    </a:p>
-                  </a:txBody>
-                  <a:tcPr marL="114300" marR="114300" marT="68580" marB="68580" anchor="ctr">
-                    <a:solidFill>
-                      <a:srgbClr val="1B2F4B"/>
-                    </a:solidFill>
-                  </a:tcPr>
-                </a:tc>
-              </a:tr>
-              <a:tr h="698500">
-                <a:tc>
-                  <a:txBody>
-                    <a:bodyPr wrap="square"/>
-                    <a:lstStyle/>
-                    <a:p>
-                      <a:pPr>
-                        <a:lnSpc>
-                          <a:spcPct val="100000"/>
-                        </a:lnSpc>
-                      </a:pPr>
-                      <a:r>
-                        <a:rPr sz="1500" b="1" i="0">
-                          <a:solidFill>
-                            <a:srgbClr val="2E3A4A"/>
-                          </a:solidFill>
-                          <a:latin typeface="Montserrat"/>
-                        </a:rPr>
-                        <a:t>Quer os trilhos:</a:t>
-                      </a:r>
-                      <a:r>
-                        <a:rPr sz="1500" b="0" i="0">
-                          <a:solidFill>
-                            <a:srgbClr val="2E3A4A"/>
-                          </a:solidFill>
-                          <a:latin typeface="Montserrat"/>
-                        </a:rPr>
-                        <a:t> “primeiro mesa, depois trem”; ensinar a pedir “mais trem” e a esperar</a:t>
-                      </a:r>
-                    </a:p>
-                  </a:txBody>
-                  <a:tcPr marL="114300" marR="114300" marT="68580" marB="68580" anchor="ctr">
-                    <a:solidFill>
-                      <a:srgbClr val="FFFFFF"/>
-                    </a:solidFill>
-                  </a:tcPr>
-                </a:tc>
-                <a:tc>
-                  <a:txBody>
-                    <a:bodyPr wrap="square"/>
-                    <a:lstStyle/>
-                    <a:p>
-                      <a:pPr>
-                        <a:lnSpc>
-                          <a:spcPct val="100000"/>
-                        </a:lnSpc>
-                      </a:pPr>
-                      <a:r>
-                        <a:rPr sz="1500" b="0" i="0">
-                          <a:solidFill>
-                            <a:srgbClr val="2E3A4A"/>
-                          </a:solidFill>
-                          <a:latin typeface="Montserrat"/>
-                        </a:rPr>
-                        <a:t>Se na verdade ele foge da mesa: pouco efeito, a mesa continua difícil</a:t>
-                      </a:r>
-                    </a:p>
-                  </a:txBody>
-                  <a:tcPr marL="114300" marR="114300" marT="68580" marB="68580" anchor="ctr">
-                    <a:solidFill>
-                      <a:srgbClr val="FFFFFF"/>
-                    </a:solidFill>
-                  </a:tcPr>
-                </a:tc>
-              </a:tr>
-              <a:tr h="698500">
-                <a:tc>
-                  <a:txBody>
-                    <a:bodyPr wrap="square"/>
-                    <a:lstStyle/>
-                    <a:p>
-                      <a:pPr>
-                        <a:lnSpc>
-                          <a:spcPct val="100000"/>
-                        </a:lnSpc>
-                      </a:pPr>
-                      <a:r>
-                        <a:rPr sz="1500" b="1" i="0">
-                          <a:solidFill>
-                            <a:srgbClr val="2E3A4A"/>
-                          </a:solidFill>
-                          <a:latin typeface="Montserrat"/>
-                        </a:rPr>
-                        <a:t>Foge da mesa:</a:t>
-                      </a:r>
-                      <a:r>
-                        <a:rPr sz="1500" b="0" i="0">
-                          <a:solidFill>
-                            <a:srgbClr val="2E3A4A"/>
-                          </a:solidFill>
-                          <a:latin typeface="Montserrat"/>
-                        </a:rPr>
-                        <a:t> tarefa mais curta, com tema de trens; ensinar a pedir “pausa”</a:t>
-                      </a:r>
-                    </a:p>
-                  </a:txBody>
-                  <a:tcPr marL="114300" marR="114300" marT="68580" marB="68580" anchor="ctr">
-                    <a:solidFill>
-                      <a:srgbClr val="F1F4F6"/>
-                    </a:solidFill>
-                  </a:tcPr>
-                </a:tc>
-                <a:tc>
-                  <a:txBody>
-                    <a:bodyPr wrap="square"/>
-                    <a:lstStyle/>
-                    <a:p>
-                      <a:pPr>
-                        <a:lnSpc>
-                          <a:spcPct val="100000"/>
-                        </a:lnSpc>
-                      </a:pPr>
-                      <a:r>
-                        <a:rPr sz="1500" b="0" i="0">
-                          <a:solidFill>
-                            <a:srgbClr val="2E3A4A"/>
-                          </a:solidFill>
-                          <a:latin typeface="Montserrat"/>
-                        </a:rPr>
-                        <a:t>Se na verdade ele quer os trilhos: o comportamento na hora de guardar continua</a:t>
-                      </a:r>
-                    </a:p>
-                  </a:txBody>
-                  <a:tcPr marL="114300" marR="114300" marT="68580" marB="68580" anchor="ctr">
-                    <a:solidFill>
-                      <a:srgbClr val="F1F4F6"/>
-                    </a:solidFill>
-                  </a:tcPr>
-                </a:tc>
-              </a:tr>
-              <a:tr h="463550">
-                <a:tc>
-                  <a:txBody>
-                    <a:bodyPr wrap="square"/>
-                    <a:lstStyle/>
-                    <a:p>
-                      <a:pPr>
-                        <a:lnSpc>
-                          <a:spcPct val="100000"/>
-                        </a:lnSpc>
-                      </a:pPr>
-                      <a:r>
-                        <a:rPr sz="1500" b="0" i="0">
-                          <a:solidFill>
-                            <a:srgbClr val="2E3A4A"/>
-                          </a:solidFill>
-                          <a:latin typeface="Montserrat"/>
-                        </a:rPr>
-                        <a:t>Adiar a mesa quando ele grita, “para acalmar”</a:t>
-                      </a:r>
-                    </a:p>
-                  </a:txBody>
-                  <a:tcPr marL="114300" marR="114300" marT="68580" marB="68580" anchor="ctr">
-                    <a:solidFill>
-                      <a:srgbClr val="FFFFFF"/>
-                    </a:solidFill>
-                  </a:tcPr>
-                </a:tc>
-                <a:tc>
-                  <a:txBody>
-                    <a:bodyPr wrap="square"/>
-                    <a:lstStyle/>
-                    <a:p>
-                      <a:pPr>
-                        <a:lnSpc>
-                          <a:spcPct val="100000"/>
-                        </a:lnSpc>
-                      </a:pPr>
-                      <a:r>
-                        <a:rPr sz="1500" b="1" i="0">
-                          <a:solidFill>
-                            <a:srgbClr val="2E3A4A"/>
-                          </a:solidFill>
-                          <a:latin typeface="Montserrat"/>
-                        </a:rPr>
-                        <a:t>Piora:</a:t>
-                      </a:r>
-                      <a:r>
-                        <a:rPr sz="1500" b="0" i="0">
-                          <a:solidFill>
-                            <a:srgbClr val="2E3A4A"/>
-                          </a:solidFill>
-                          <a:latin typeface="Montserrat"/>
-                        </a:rPr>
-                        <a:t> ele aprende que gritar funciona</a:t>
-                      </a:r>
-                    </a:p>
-                  </a:txBody>
-                  <a:tcPr marL="114300" marR="114300" marT="68580" marB="68580" anchor="ctr">
-                    <a:solidFill>
-                      <a:srgbClr val="FFFFFF"/>
-                    </a:solidFill>
-                  </a:tcPr>
-                </a:tc>
-              </a:tr>
-            </a:tbl>
-          </a:graphicData>
-        </a:graphic>
-      </p:graphicFrame>
-      <p:sp>
-        <p:nvSpPr>
-          <p:cNvPr id="5" name="TextBox 4"/>
-          <p:cNvSpPr txBox="1"/>
-          <p:nvPr/>
-        </p:nvSpPr>
-        <p:spPr>
-          <a:xfrm>
-            <a:off x="1168400" y="4993580"/>
-            <a:ext cx="10307828" cy="330200"/>
-          </a:xfrm>
-          <a:prstGeom prst="rect">
-            <a:avLst/>
-          </a:prstGeom>
-          <a:noFill/>
-        </p:spPr>
-        <p:txBody>
-          <a:bodyPr wrap="square" lIns="0" rIns="0" tIns="0" bIns="0" anchor="t">
-            <a:noAutofit/>
-          </a:bodyPr>
-          <a:lstStyle/>
-          <a:p>
-            <a:pPr algn="l">
-              <a:lnSpc>
-                <a:spcPct val="107000"/>
-              </a:lnSpc>
-            </a:pPr>
-            <a:r>
-              <a:rPr sz="2000" b="1" i="0">
-                <a:solidFill>
-                  <a:srgbClr val="0F7C86"/>
-                </a:solidFill>
-                <a:latin typeface="Montserrat"/>
-              </a:rPr>
-              <a:t>Errar a explicação pode ensinar o contrário do que queremos.</a:t>
-            </a:r>
-          </a:p>
-        </p:txBody>
-      </p:sp>
-      <p:sp>
-        <p:nvSpPr>
-          <p:cNvPr id="6" name="TextBox 5"/>
+              <a:t>Escolher a explicação errada pode não ajudar e até piorar. Por isso, avaliar vem antes de intervir.</a:t>
+            </a:r>
+          </a:p>
+        </p:txBody>
+      </p:sp>
+      <p:sp>
+        <p:nvSpPr>
+          <p:cNvPr id="8" name="TextBox 7"/>
           <p:cNvSpPr txBox="1"/>
           <p:nvPr/>
         </p:nvSpPr>
@@ -23123,7 +23266,7 @@
                 </a:solidFill>
                 <a:latin typeface="Montserrat"/>
               </a:rPr>
-              <a:t> se a função for fugir da mesa, o comportamento continua</a:t>
+              <a:t> se ele quer escapar da mesa, o grito continua mesmo sem os trilhos</a:t>
             </a:r>
           </a:p>
           <a:p>
@@ -23715,7 +23858,7 @@
                 </a:solidFill>
                 <a:latin typeface="Montserrat"/>
               </a:rPr>
-              <a:t>Fica mais forte a explicação “quer os trilhos” (ou as duas juntas): sem guardar os trilhos, quase não houve episódio. “Foge da mesa” fica mais fraca.</a:t>
+              <a:t>Fica mais forte a explicação “quer os trilhos” (ou as duas juntas): sem guardar os trilhos, quase não houve episódio. “Escapar da mesa” fica mais fraca.</a:t>
             </a:r>
           </a:p>
         </p:txBody>

</xml_diff>

<commit_message>
Slide 7: dois domínios de sinais e os critérios C, D e E do DSM-5-TR
Co-Authored-By: Claude Opus 5.5 <noreply@anthropic.com>
Claude-Session: https://claude.ai/code/session_013ZYQJsTZixhcpCnj3mHGtq
</commit_message>
<xml_diff>
--- a/workshop-aba-tea-lacc/apresentacao/Apresentacao_Workshop_ABA_TEA.pptx
+++ b/workshop-aba-tea-lacc/apresentacao/Apresentacao_Workshop_ABA_TEA.pptx
@@ -4706,7 +4706,7 @@
           <a:lstStyle/>
           <a:p>
             <a:r>
-              <a:t>O manual usa o termo "déficits"; o slide usa "diferenças" por coerência com a linguagem do workshop. Ao falar, mencionar que o texto diagnóstico usa "déficits". No domínio B, citar as quatro formas (movimentos, fala ou uso de objetos estereotipados; insistência na mesmice; interesses restritos e intensos; hiper ou hiporreatividade sensorial), das quais pelo menos duas são necessárias. Se perguntarem "só duas áreas?": sim. No DSM-IV havia a tríade (interação social, comunicação, comportamentos repetitivos); o DSM-5 juntou interação social e comunicação em um domínio, e o atraso de linguagem passou a ser especificador. Os outros critérios (C, D e E) são: sinais no início do desenvolvimento, prejuízo significativo e não ser melhor explicado por deficiência intelectual. Conferir a redação na edição em uso. Tempo: 3 min (início do Bloco 1, 9h40).</a:t>
+              <a:t>O manual usa o termo "déficits"; o slide usa "diferenças" por coerência com a linguagem do workshop. Ao falar, mencionar que o texto diagnóstico usa "déficits". No domínio B, citar as quatro formas (movimentos, fala ou uso de objetos estereotipados; insistência na mesmice; interesses restritos e intensos; hiper ou hiporreatividade sensorial), das quais pelo menos duas são necessárias. Se perguntarem "só duas áreas?": os sinais centrais ficam em dois domínios, mas o diagnóstico exige os cinco critérios (A a E). No DSM-IV havia a tríade (interação social, comunicação, comportamentos repetitivos); o DSM-5 juntou interação social e comunicação em um domínio, e o atraso de linguagem passou a ser especificador. Os outros critérios (C, D e E) são: sinais no início do desenvolvimento, prejuízo significativo e não ser melhor explicado por deficiência intelectual. Conferir a redação na edição em uso. Tempo: 3 min (início do Bloco 1, 9h40).</a:t>
             </a:r>
           </a:p>
         </p:txBody>
@@ -29628,8 +29628,8 @@
         </p:nvSpPr>
         <p:spPr>
           <a:xfrm>
-            <a:off x="1168400" y="977602"/>
-            <a:ext cx="10307828" cy="963811"/>
+            <a:off x="1168400" y="1516757"/>
+            <a:ext cx="10307828" cy="817761"/>
           </a:xfrm>
           <a:prstGeom prst="rect">
             <a:avLst/>
@@ -29648,13 +29648,13 @@
               </a:lnSpc>
             </a:pPr>
             <a:r>
-              <a:rPr sz="3300" b="1" i="0">
+              <a:rPr sz="2800" b="1" i="0">
                 <a:solidFill>
                   <a:srgbClr val="1B2F4B"/>
                 </a:solidFill>
                 <a:latin typeface="Montserrat"/>
               </a:rPr>
-              <a:t>O diagnóstico de TEA se apoia em dois domínios (áreas)</a:t>
+              <a:t>Diagnóstico de TEA: dois domínios de sinais e mais três critérios</a:t>
             </a:r>
           </a:p>
         </p:txBody>
@@ -29667,8 +29667,8 @@
         </p:nvSpPr>
         <p:spPr>
           <a:xfrm>
-            <a:off x="1168400" y="2195413"/>
-            <a:ext cx="4839970" cy="319980"/>
+            <a:off x="1168400" y="2512318"/>
+            <a:ext cx="4918456" cy="274241"/>
           </a:xfrm>
           <a:prstGeom prst="rect">
             <a:avLst/>
@@ -29687,13 +29687,13 @@
               </a:lnSpc>
             </a:pPr>
             <a:r>
-              <a:rPr sz="2100" b="1" i="0">
+              <a:rPr sz="1800" b="1" i="0">
                 <a:solidFill>
                   <a:srgbClr val="0F7C86"/>
                 </a:solidFill>
                 <a:latin typeface="Montserrat"/>
               </a:rPr>
-              <a:t>Comunicação e interação social</a:t>
+              <a:t>A. Comunicação e interação social</a:t>
             </a:r>
           </a:p>
         </p:txBody>
@@ -29706,8 +29706,8 @@
         </p:nvSpPr>
         <p:spPr>
           <a:xfrm>
-            <a:off x="1168400" y="2604294"/>
-            <a:ext cx="4839970" cy="675481"/>
+            <a:off x="1168400" y="2850059"/>
+            <a:ext cx="4918456" cy="995362"/>
           </a:xfrm>
           <a:prstGeom prst="rect">
             <a:avLst/>
@@ -29726,13 +29726,31 @@
               </a:lnSpc>
             </a:pPr>
             <a:r>
-              <a:rPr sz="1900" b="0" i="0">
+              <a:rPr sz="1400" b="0" i="0">
                 <a:solidFill>
                   <a:srgbClr val="2E3A4A"/>
                 </a:solidFill>
                 <a:latin typeface="Montserrat"/>
               </a:rPr>
-              <a:t>Diferenças persistentes, em vários contextos.</a:t>
+              <a:t>Diferenças persistentes, em vários contextos. Precisa das </a:t>
+            </a:r>
+            <a:r>
+              <a:rPr sz="1400" b="1" i="0">
+                <a:solidFill>
+                  <a:srgbClr val="2E3A4A"/>
+                </a:solidFill>
+                <a:latin typeface="Montserrat"/>
+              </a:rPr>
+              <a:t>três</a:t>
+            </a:r>
+            <a:r>
+              <a:rPr sz="1400" b="0" i="0">
+                <a:solidFill>
+                  <a:srgbClr val="2E3A4A"/>
+                </a:solidFill>
+                <a:latin typeface="Montserrat"/>
+              </a:rPr>
+              <a:t>: reciprocidade socioemocional (troca com o outro), comunicação não verbal (olhar, gestos, expressões) e criar e manter relacionamentos.</a:t>
             </a:r>
           </a:p>
         </p:txBody>
@@ -29745,8 +29763,8 @@
         </p:nvSpPr>
         <p:spPr>
           <a:xfrm>
-            <a:off x="6477000" y="2195413"/>
-            <a:ext cx="4839970" cy="319980"/>
+            <a:off x="6400800" y="2512318"/>
+            <a:ext cx="4918456" cy="274241"/>
           </a:xfrm>
           <a:prstGeom prst="rect">
             <a:avLst/>
@@ -29765,13 +29783,13 @@
               </a:lnSpc>
             </a:pPr>
             <a:r>
-              <a:rPr sz="2100" b="1" i="0">
+              <a:rPr sz="1800" b="1" i="0">
                 <a:solidFill>
                   <a:srgbClr val="0F7C86"/>
                 </a:solidFill>
                 <a:latin typeface="Montserrat"/>
               </a:rPr>
-              <a:t>Padrões restritos e repetitivos</a:t>
+              <a:t>B. Padrões restritos e repetitivos</a:t>
             </a:r>
           </a:p>
         </p:txBody>
@@ -29784,8 +29802,8 @@
         </p:nvSpPr>
         <p:spPr>
           <a:xfrm>
-            <a:off x="6477000" y="2604294"/>
-            <a:ext cx="4839970" cy="1350962"/>
+            <a:off x="6400800" y="2850059"/>
+            <a:ext cx="4918456" cy="995362"/>
           </a:xfrm>
           <a:prstGeom prst="rect">
             <a:avLst/>
@@ -29804,13 +29822,31 @@
               </a:lnSpc>
             </a:pPr>
             <a:r>
-              <a:rPr sz="1900" b="0" i="0">
+              <a:rPr sz="1400" b="0" i="0">
                 <a:solidFill>
                   <a:srgbClr val="2E3A4A"/>
                 </a:solidFill>
                 <a:latin typeface="Montserrat"/>
               </a:rPr>
-              <a:t>De comportamento, interesses ou atividades, incluindo respostas sensoriais (reações a sons, luzes, texturas).</a:t>
+              <a:t>Precisa de </a:t>
+            </a:r>
+            <a:r>
+              <a:rPr sz="1400" b="1" i="0">
+                <a:solidFill>
+                  <a:srgbClr val="2E3A4A"/>
+                </a:solidFill>
+                <a:latin typeface="Montserrat"/>
+              </a:rPr>
+              <a:t>pelo menos duas</a:t>
+            </a:r>
+            <a:r>
+              <a:rPr sz="1400" b="0" i="0">
+                <a:solidFill>
+                  <a:srgbClr val="2E3A4A"/>
+                </a:solidFill>
+                <a:latin typeface="Montserrat"/>
+              </a:rPr>
+              <a:t> de quatro: movimentos ou fala repetitivos; insistência na mesmice (rotinas rígidas); interesses restritos e intensos; respostas sensoriais (reações a sons, luzes, texturas).</a:t>
             </a:r>
           </a:p>
         </p:txBody>
@@ -29823,8 +29859,8 @@
         </p:nvSpPr>
         <p:spPr>
           <a:xfrm>
-            <a:off x="1168400" y="4209256"/>
-            <a:ext cx="10307828" cy="959941"/>
+            <a:off x="1168400" y="4023221"/>
+            <a:ext cx="10307828" cy="497681"/>
           </a:xfrm>
           <a:prstGeom prst="rect">
             <a:avLst/>
@@ -29843,13 +29879,22 @@
               </a:lnSpc>
             </a:pPr>
             <a:r>
-              <a:rPr sz="1800" b="0" i="0">
+              <a:rPr sz="1400" b="1" i="0">
                 <a:solidFill>
                   <a:srgbClr val="2E3A4A"/>
                 </a:solidFill>
                 <a:latin typeface="Montserrat"/>
               </a:rPr>
-              <a:t>Os sinais aparecem no início do desenvolvimento e têm impacto significativo no funcionamento (DSM-5-TR: manual de diagnóstico da Associação Americana de Psiquiatria).</a:t>
+              <a:t>Além disso:</a:t>
+            </a:r>
+            <a:r>
+              <a:rPr sz="1400" b="0" i="0">
+                <a:solidFill>
+                  <a:srgbClr val="2E3A4A"/>
+                </a:solidFill>
+                <a:latin typeface="Montserrat"/>
+              </a:rPr>
+              <a:t> C. os sinais aparecem no início do desenvolvimento; D. causam prejuízo significativo no dia a dia; E. não são melhor explicados por deficiência intelectual ou atraso global do desenvolvimento.</a:t>
             </a:r>
           </a:p>
         </p:txBody>
@@ -29862,8 +29907,8 @@
         </p:nvSpPr>
         <p:spPr>
           <a:xfrm>
-            <a:off x="1168400" y="5423198"/>
-            <a:ext cx="10307828" cy="266700"/>
+            <a:off x="1168400" y="4698702"/>
+            <a:ext cx="10307828" cy="426641"/>
           </a:xfrm>
           <a:prstGeom prst="rect">
             <a:avLst/>
@@ -29882,13 +29927,13 @@
               </a:lnSpc>
             </a:pPr>
             <a:r>
-              <a:rPr sz="1500" b="0" i="1">
+              <a:rPr sz="1200" b="0" i="1">
                 <a:solidFill>
                   <a:srgbClr val="66717F"/>
                 </a:solidFill>
                 <a:latin typeface="Montserrat"/>
               </a:rPr>
-              <a:t>No DSM-IV eram três áreas. Desde o DSM-5, comunicação e interação social formam um único domínio.</a:t>
+              <a:t>DSM-5-TR: manual de diagnóstico da Associação Americana de Psiquiatria. No DSM-IV eram três áreas; desde o DSM-5, comunicação e interação social formam um único domínio.</a:t>
             </a:r>
           </a:p>
         </p:txBody>

</xml_diff>